<commit_message>
Combine Tom's Lessons 7 & 8 into one merged lesson (market failure: definitions, causes & consequences)
Lesson 7 now covers the full 2.9 topic in one longer session; lesson-08
(now redundant) is removed and every later lesson shifts back one slot
(old lesson-09 "Mixed economy" is now lesson-08, etc). Regenerated
dashboard/data and rebuilt worksheet.docx/slides.pptx for all lessons.
</commit_message>
<xml_diff>
--- a/courses/tom-economics/lessons/lesson-07/slides.pptx
+++ b/courses/tom-economics/lessons/lesson-07/slides.pptx
@@ -26,9 +26,18 @@
     <p:sldId id="274" r:id="rId20"/>
     <p:sldId id="275" r:id="rId21"/>
     <p:sldId id="276" r:id="rId22"/>
+    <p:sldId id="277" r:id="rId23"/>
+    <p:sldId id="278" r:id="rId24"/>
+    <p:sldId id="279" r:id="rId25"/>
+    <p:sldId id="280" r:id="rId26"/>
+    <p:sldId id="281" r:id="rId27"/>
+    <p:sldId id="282" r:id="rId28"/>
+    <p:sldId id="283" r:id="rId29"/>
+    <p:sldId id="284" r:id="rId30"/>
+    <p:sldId id="285" r:id="rId31"/>
   </p:sldIdLst>
   <p:notesMasterIdLst>
-    <p:notesMasterId r:id="rId23"/>
+    <p:notesMasterId r:id="rId32"/>
   </p:notesMasterIdLst>
   <p:sldSz cx="12192000" cy="6858000"/>
   <p:notesSz cx="6858000" cy="12192000"/>
@@ -1708,6 +1717,710 @@
 </p:notes>
 </file>
 
+<file path=ppt/notesSlides/notesSlide22.xml><?xml version="1.0" encoding="utf-8"?>
+<p:notes xmlns:a="http://schemas.openxmlformats.org/drawingml/2006/main" xmlns:r="http://schemas.openxmlformats.org/officeDocument/2006/relationships" xmlns:p="http://schemas.openxmlformats.org/presentationml/2006/main">
+  <p:cSld>
+    <p:spTree>
+      <p:nvGrpSpPr>
+        <p:cNvPr id="1" name=""/>
+        <p:cNvGrpSpPr/>
+        <p:nvPr/>
+      </p:nvGrpSpPr>
+      <p:grpSpPr>
+        <a:xfrm>
+          <a:off x="0" y="0"/>
+          <a:ext cx="0" cy="0"/>
+          <a:chOff x="0" y="0"/>
+          <a:chExt cx="0" cy="0"/>
+        </a:xfrm>
+      </p:grpSpPr>
+      <p:sp>
+        <p:nvSpPr>
+          <p:cNvPr id="2" name="Slide Image Placeholder 1"/>
+          <p:cNvSpPr>
+            <a:spLocks noGrp="1" noRot="1" noChangeAspect="1"/>
+          </p:cNvSpPr>
+          <p:nvPr>
+            <p:ph type="sldImg"/>
+          </p:nvPr>
+        </p:nvSpPr>
+        <p:spPr/>
+      </p:sp>
+      <p:sp>
+        <p:nvSpPr>
+          <p:cNvPr id="3" name="Notes Placeholder 2"/>
+          <p:cNvSpPr>
+            <a:spLocks noGrp="1"/>
+          </p:cNvSpPr>
+          <p:nvPr>
+            <p:ph type="body" idx="1"/>
+          </p:nvPr>
+        </p:nvSpPr>
+        <p:spPr/>
+        <p:txBody>
+          <a:bodyPr/>
+          <a:lstStyle/>
+          <a:p>
+            <a:r>
+              <a:rPr lang="en-US" dirty="0"/>
+              <a:t/>
+            </a:r>
+            <a:endParaRPr lang="en-US" dirty="0"/>
+          </a:p>
+        </p:txBody>
+      </p:sp>
+      <p:sp>
+        <p:nvSpPr>
+          <p:cNvPr id="4" name="Slide Number Placeholder 3"/>
+          <p:cNvSpPr>
+            <a:spLocks noGrp="1"/>
+          </p:cNvSpPr>
+          <p:nvPr>
+            <p:ph type="sldNum" sz="quarter" idx="10"/>
+          </p:nvPr>
+        </p:nvSpPr>
+        <p:spPr/>
+        <p:txBody>
+          <a:bodyPr/>
+          <a:lstStyle/>
+          <a:p>
+            <a:fld id="{F7021451-1387-4CA6-816F-3879F97B5CBC}" type="slidenum">
+              <a:rPr lang="en-US"/>
+              <a:t>22</a:t>
+            </a:fld>
+            <a:endParaRPr lang="en-US"/>
+          </a:p>
+        </p:txBody>
+      </p:sp>
+    </p:spTree>
+    <p:extLst>
+      <p:ext uri="{BB962C8B-B14F-4D97-AF65-F5344CB8AC3E}">
+        <p14:creationId xmlns:p14="http://schemas.microsoft.com/office/powerpoint/2010/main" val="1024086991"/>
+      </p:ext>
+    </p:extLst>
+  </p:cSld>
+  <p:clrMapOvr>
+    <a:masterClrMapping/>
+  </p:clrMapOvr>
+</p:notes>
+</file>
+
+<file path=ppt/notesSlides/notesSlide23.xml><?xml version="1.0" encoding="utf-8"?>
+<p:notes xmlns:a="http://schemas.openxmlformats.org/drawingml/2006/main" xmlns:r="http://schemas.openxmlformats.org/officeDocument/2006/relationships" xmlns:p="http://schemas.openxmlformats.org/presentationml/2006/main">
+  <p:cSld>
+    <p:spTree>
+      <p:nvGrpSpPr>
+        <p:cNvPr id="1" name=""/>
+        <p:cNvGrpSpPr/>
+        <p:nvPr/>
+      </p:nvGrpSpPr>
+      <p:grpSpPr>
+        <a:xfrm>
+          <a:off x="0" y="0"/>
+          <a:ext cx="0" cy="0"/>
+          <a:chOff x="0" y="0"/>
+          <a:chExt cx="0" cy="0"/>
+        </a:xfrm>
+      </p:grpSpPr>
+      <p:sp>
+        <p:nvSpPr>
+          <p:cNvPr id="2" name="Slide Image Placeholder 1"/>
+          <p:cNvSpPr>
+            <a:spLocks noGrp="1" noRot="1" noChangeAspect="1"/>
+          </p:cNvSpPr>
+          <p:nvPr>
+            <p:ph type="sldImg"/>
+          </p:nvPr>
+        </p:nvSpPr>
+        <p:spPr/>
+      </p:sp>
+      <p:sp>
+        <p:nvSpPr>
+          <p:cNvPr id="3" name="Notes Placeholder 2"/>
+          <p:cNvSpPr>
+            <a:spLocks noGrp="1"/>
+          </p:cNvSpPr>
+          <p:nvPr>
+            <p:ph type="body" idx="1"/>
+          </p:nvPr>
+        </p:nvSpPr>
+        <p:spPr/>
+        <p:txBody>
+          <a:bodyPr/>
+          <a:lstStyle/>
+          <a:p>
+            <a:r>
+              <a:rPr lang="en-US" dirty="0"/>
+              <a:t/>
+            </a:r>
+            <a:endParaRPr lang="en-US" dirty="0"/>
+          </a:p>
+        </p:txBody>
+      </p:sp>
+      <p:sp>
+        <p:nvSpPr>
+          <p:cNvPr id="4" name="Slide Number Placeholder 3"/>
+          <p:cNvSpPr>
+            <a:spLocks noGrp="1"/>
+          </p:cNvSpPr>
+          <p:nvPr>
+            <p:ph type="sldNum" sz="quarter" idx="10"/>
+          </p:nvPr>
+        </p:nvSpPr>
+        <p:spPr/>
+        <p:txBody>
+          <a:bodyPr/>
+          <a:lstStyle/>
+          <a:p>
+            <a:fld id="{F7021451-1387-4CA6-816F-3879F97B5CBC}" type="slidenum">
+              <a:rPr lang="en-US"/>
+              <a:t>23</a:t>
+            </a:fld>
+            <a:endParaRPr lang="en-US"/>
+          </a:p>
+        </p:txBody>
+      </p:sp>
+    </p:spTree>
+    <p:extLst>
+      <p:ext uri="{BB962C8B-B14F-4D97-AF65-F5344CB8AC3E}">
+        <p14:creationId xmlns:p14="http://schemas.microsoft.com/office/powerpoint/2010/main" val="1024086991"/>
+      </p:ext>
+    </p:extLst>
+  </p:cSld>
+  <p:clrMapOvr>
+    <a:masterClrMapping/>
+  </p:clrMapOvr>
+</p:notes>
+</file>
+
+<file path=ppt/notesSlides/notesSlide24.xml><?xml version="1.0" encoding="utf-8"?>
+<p:notes xmlns:a="http://schemas.openxmlformats.org/drawingml/2006/main" xmlns:r="http://schemas.openxmlformats.org/officeDocument/2006/relationships" xmlns:p="http://schemas.openxmlformats.org/presentationml/2006/main">
+  <p:cSld>
+    <p:spTree>
+      <p:nvGrpSpPr>
+        <p:cNvPr id="1" name=""/>
+        <p:cNvGrpSpPr/>
+        <p:nvPr/>
+      </p:nvGrpSpPr>
+      <p:grpSpPr>
+        <a:xfrm>
+          <a:off x="0" y="0"/>
+          <a:ext cx="0" cy="0"/>
+          <a:chOff x="0" y="0"/>
+          <a:chExt cx="0" cy="0"/>
+        </a:xfrm>
+      </p:grpSpPr>
+      <p:sp>
+        <p:nvSpPr>
+          <p:cNvPr id="2" name="Slide Image Placeholder 1"/>
+          <p:cNvSpPr>
+            <a:spLocks noGrp="1" noRot="1" noChangeAspect="1"/>
+          </p:cNvSpPr>
+          <p:nvPr>
+            <p:ph type="sldImg"/>
+          </p:nvPr>
+        </p:nvSpPr>
+        <p:spPr/>
+      </p:sp>
+      <p:sp>
+        <p:nvSpPr>
+          <p:cNvPr id="3" name="Notes Placeholder 2"/>
+          <p:cNvSpPr>
+            <a:spLocks noGrp="1"/>
+          </p:cNvSpPr>
+          <p:nvPr>
+            <p:ph type="body" idx="1"/>
+          </p:nvPr>
+        </p:nvSpPr>
+        <p:spPr/>
+        <p:txBody>
+          <a:bodyPr/>
+          <a:lstStyle/>
+          <a:p>
+            <a:r>
+              <a:rPr lang="en-US" dirty="0"/>
+              <a:t/>
+            </a:r>
+            <a:endParaRPr lang="en-US" dirty="0"/>
+          </a:p>
+        </p:txBody>
+      </p:sp>
+      <p:sp>
+        <p:nvSpPr>
+          <p:cNvPr id="4" name="Slide Number Placeholder 3"/>
+          <p:cNvSpPr>
+            <a:spLocks noGrp="1"/>
+          </p:cNvSpPr>
+          <p:nvPr>
+            <p:ph type="sldNum" sz="quarter" idx="10"/>
+          </p:nvPr>
+        </p:nvSpPr>
+        <p:spPr/>
+        <p:txBody>
+          <a:bodyPr/>
+          <a:lstStyle/>
+          <a:p>
+            <a:fld id="{F7021451-1387-4CA6-816F-3879F97B5CBC}" type="slidenum">
+              <a:rPr lang="en-US"/>
+              <a:t>24</a:t>
+            </a:fld>
+            <a:endParaRPr lang="en-US"/>
+          </a:p>
+        </p:txBody>
+      </p:sp>
+    </p:spTree>
+    <p:extLst>
+      <p:ext uri="{BB962C8B-B14F-4D97-AF65-F5344CB8AC3E}">
+        <p14:creationId xmlns:p14="http://schemas.microsoft.com/office/powerpoint/2010/main" val="1024086991"/>
+      </p:ext>
+    </p:extLst>
+  </p:cSld>
+  <p:clrMapOvr>
+    <a:masterClrMapping/>
+  </p:clrMapOvr>
+</p:notes>
+</file>
+
+<file path=ppt/notesSlides/notesSlide25.xml><?xml version="1.0" encoding="utf-8"?>
+<p:notes xmlns:a="http://schemas.openxmlformats.org/drawingml/2006/main" xmlns:r="http://schemas.openxmlformats.org/officeDocument/2006/relationships" xmlns:p="http://schemas.openxmlformats.org/presentationml/2006/main">
+  <p:cSld>
+    <p:spTree>
+      <p:nvGrpSpPr>
+        <p:cNvPr id="1" name=""/>
+        <p:cNvGrpSpPr/>
+        <p:nvPr/>
+      </p:nvGrpSpPr>
+      <p:grpSpPr>
+        <a:xfrm>
+          <a:off x="0" y="0"/>
+          <a:ext cx="0" cy="0"/>
+          <a:chOff x="0" y="0"/>
+          <a:chExt cx="0" cy="0"/>
+        </a:xfrm>
+      </p:grpSpPr>
+      <p:sp>
+        <p:nvSpPr>
+          <p:cNvPr id="2" name="Slide Image Placeholder 1"/>
+          <p:cNvSpPr>
+            <a:spLocks noGrp="1" noRot="1" noChangeAspect="1"/>
+          </p:cNvSpPr>
+          <p:nvPr>
+            <p:ph type="sldImg"/>
+          </p:nvPr>
+        </p:nvSpPr>
+        <p:spPr/>
+      </p:sp>
+      <p:sp>
+        <p:nvSpPr>
+          <p:cNvPr id="3" name="Notes Placeholder 2"/>
+          <p:cNvSpPr>
+            <a:spLocks noGrp="1"/>
+          </p:cNvSpPr>
+          <p:nvPr>
+            <p:ph type="body" idx="1"/>
+          </p:nvPr>
+        </p:nvSpPr>
+        <p:spPr/>
+        <p:txBody>
+          <a:bodyPr/>
+          <a:lstStyle/>
+          <a:p>
+            <a:r>
+              <a:rPr lang="en-US" dirty="0"/>
+              <a:t/>
+            </a:r>
+            <a:endParaRPr lang="en-US" dirty="0"/>
+          </a:p>
+        </p:txBody>
+      </p:sp>
+      <p:sp>
+        <p:nvSpPr>
+          <p:cNvPr id="4" name="Slide Number Placeholder 3"/>
+          <p:cNvSpPr>
+            <a:spLocks noGrp="1"/>
+          </p:cNvSpPr>
+          <p:nvPr>
+            <p:ph type="sldNum" sz="quarter" idx="10"/>
+          </p:nvPr>
+        </p:nvSpPr>
+        <p:spPr/>
+        <p:txBody>
+          <a:bodyPr/>
+          <a:lstStyle/>
+          <a:p>
+            <a:fld id="{F7021451-1387-4CA6-816F-3879F97B5CBC}" type="slidenum">
+              <a:rPr lang="en-US"/>
+              <a:t>25</a:t>
+            </a:fld>
+            <a:endParaRPr lang="en-US"/>
+          </a:p>
+        </p:txBody>
+      </p:sp>
+    </p:spTree>
+    <p:extLst>
+      <p:ext uri="{BB962C8B-B14F-4D97-AF65-F5344CB8AC3E}">
+        <p14:creationId xmlns:p14="http://schemas.microsoft.com/office/powerpoint/2010/main" val="1024086991"/>
+      </p:ext>
+    </p:extLst>
+  </p:cSld>
+  <p:clrMapOvr>
+    <a:masterClrMapping/>
+  </p:clrMapOvr>
+</p:notes>
+</file>
+
+<file path=ppt/notesSlides/notesSlide26.xml><?xml version="1.0" encoding="utf-8"?>
+<p:notes xmlns:a="http://schemas.openxmlformats.org/drawingml/2006/main" xmlns:r="http://schemas.openxmlformats.org/officeDocument/2006/relationships" xmlns:p="http://schemas.openxmlformats.org/presentationml/2006/main">
+  <p:cSld>
+    <p:spTree>
+      <p:nvGrpSpPr>
+        <p:cNvPr id="1" name=""/>
+        <p:cNvGrpSpPr/>
+        <p:nvPr/>
+      </p:nvGrpSpPr>
+      <p:grpSpPr>
+        <a:xfrm>
+          <a:off x="0" y="0"/>
+          <a:ext cx="0" cy="0"/>
+          <a:chOff x="0" y="0"/>
+          <a:chExt cx="0" cy="0"/>
+        </a:xfrm>
+      </p:grpSpPr>
+      <p:sp>
+        <p:nvSpPr>
+          <p:cNvPr id="2" name="Slide Image Placeholder 1"/>
+          <p:cNvSpPr>
+            <a:spLocks noGrp="1" noRot="1" noChangeAspect="1"/>
+          </p:cNvSpPr>
+          <p:nvPr>
+            <p:ph type="sldImg"/>
+          </p:nvPr>
+        </p:nvSpPr>
+        <p:spPr/>
+      </p:sp>
+      <p:sp>
+        <p:nvSpPr>
+          <p:cNvPr id="3" name="Notes Placeholder 2"/>
+          <p:cNvSpPr>
+            <a:spLocks noGrp="1"/>
+          </p:cNvSpPr>
+          <p:nvPr>
+            <p:ph type="body" idx="1"/>
+          </p:nvPr>
+        </p:nvSpPr>
+        <p:spPr/>
+        <p:txBody>
+          <a:bodyPr/>
+          <a:lstStyle/>
+          <a:p>
+            <a:r>
+              <a:rPr lang="en-US" dirty="0"/>
+              <a:t/>
+            </a:r>
+            <a:endParaRPr lang="en-US" dirty="0"/>
+          </a:p>
+        </p:txBody>
+      </p:sp>
+      <p:sp>
+        <p:nvSpPr>
+          <p:cNvPr id="4" name="Slide Number Placeholder 3"/>
+          <p:cNvSpPr>
+            <a:spLocks noGrp="1"/>
+          </p:cNvSpPr>
+          <p:nvPr>
+            <p:ph type="sldNum" sz="quarter" idx="10"/>
+          </p:nvPr>
+        </p:nvSpPr>
+        <p:spPr/>
+        <p:txBody>
+          <a:bodyPr/>
+          <a:lstStyle/>
+          <a:p>
+            <a:fld id="{F7021451-1387-4CA6-816F-3879F97B5CBC}" type="slidenum">
+              <a:rPr lang="en-US"/>
+              <a:t>26</a:t>
+            </a:fld>
+            <a:endParaRPr lang="en-US"/>
+          </a:p>
+        </p:txBody>
+      </p:sp>
+    </p:spTree>
+    <p:extLst>
+      <p:ext uri="{BB962C8B-B14F-4D97-AF65-F5344CB8AC3E}">
+        <p14:creationId xmlns:p14="http://schemas.microsoft.com/office/powerpoint/2010/main" val="1024086991"/>
+      </p:ext>
+    </p:extLst>
+  </p:cSld>
+  <p:clrMapOvr>
+    <a:masterClrMapping/>
+  </p:clrMapOvr>
+</p:notes>
+</file>
+
+<file path=ppt/notesSlides/notesSlide27.xml><?xml version="1.0" encoding="utf-8"?>
+<p:notes xmlns:a="http://schemas.openxmlformats.org/drawingml/2006/main" xmlns:r="http://schemas.openxmlformats.org/officeDocument/2006/relationships" xmlns:p="http://schemas.openxmlformats.org/presentationml/2006/main">
+  <p:cSld>
+    <p:spTree>
+      <p:nvGrpSpPr>
+        <p:cNvPr id="1" name=""/>
+        <p:cNvGrpSpPr/>
+        <p:nvPr/>
+      </p:nvGrpSpPr>
+      <p:grpSpPr>
+        <a:xfrm>
+          <a:off x="0" y="0"/>
+          <a:ext cx="0" cy="0"/>
+          <a:chOff x="0" y="0"/>
+          <a:chExt cx="0" cy="0"/>
+        </a:xfrm>
+      </p:grpSpPr>
+      <p:sp>
+        <p:nvSpPr>
+          <p:cNvPr id="2" name="Slide Image Placeholder 1"/>
+          <p:cNvSpPr>
+            <a:spLocks noGrp="1" noRot="1" noChangeAspect="1"/>
+          </p:cNvSpPr>
+          <p:nvPr>
+            <p:ph type="sldImg"/>
+          </p:nvPr>
+        </p:nvSpPr>
+        <p:spPr/>
+      </p:sp>
+      <p:sp>
+        <p:nvSpPr>
+          <p:cNvPr id="3" name="Notes Placeholder 2"/>
+          <p:cNvSpPr>
+            <a:spLocks noGrp="1"/>
+          </p:cNvSpPr>
+          <p:nvPr>
+            <p:ph type="body" idx="1"/>
+          </p:nvPr>
+        </p:nvSpPr>
+        <p:spPr/>
+        <p:txBody>
+          <a:bodyPr/>
+          <a:lstStyle/>
+          <a:p>
+            <a:r>
+              <a:rPr lang="en-US" dirty="0"/>
+              <a:t/>
+            </a:r>
+            <a:endParaRPr lang="en-US" dirty="0"/>
+          </a:p>
+        </p:txBody>
+      </p:sp>
+      <p:sp>
+        <p:nvSpPr>
+          <p:cNvPr id="4" name="Slide Number Placeholder 3"/>
+          <p:cNvSpPr>
+            <a:spLocks noGrp="1"/>
+          </p:cNvSpPr>
+          <p:nvPr>
+            <p:ph type="sldNum" sz="quarter" idx="10"/>
+          </p:nvPr>
+        </p:nvSpPr>
+        <p:spPr/>
+        <p:txBody>
+          <a:bodyPr/>
+          <a:lstStyle/>
+          <a:p>
+            <a:fld id="{F7021451-1387-4CA6-816F-3879F97B5CBC}" type="slidenum">
+              <a:rPr lang="en-US"/>
+              <a:t>27</a:t>
+            </a:fld>
+            <a:endParaRPr lang="en-US"/>
+          </a:p>
+        </p:txBody>
+      </p:sp>
+    </p:spTree>
+    <p:extLst>
+      <p:ext uri="{BB962C8B-B14F-4D97-AF65-F5344CB8AC3E}">
+        <p14:creationId xmlns:p14="http://schemas.microsoft.com/office/powerpoint/2010/main" val="1024086991"/>
+      </p:ext>
+    </p:extLst>
+  </p:cSld>
+  <p:clrMapOvr>
+    <a:masterClrMapping/>
+  </p:clrMapOvr>
+</p:notes>
+</file>
+
+<file path=ppt/notesSlides/notesSlide28.xml><?xml version="1.0" encoding="utf-8"?>
+<p:notes xmlns:a="http://schemas.openxmlformats.org/drawingml/2006/main" xmlns:r="http://schemas.openxmlformats.org/officeDocument/2006/relationships" xmlns:p="http://schemas.openxmlformats.org/presentationml/2006/main">
+  <p:cSld>
+    <p:spTree>
+      <p:nvGrpSpPr>
+        <p:cNvPr id="1" name=""/>
+        <p:cNvGrpSpPr/>
+        <p:nvPr/>
+      </p:nvGrpSpPr>
+      <p:grpSpPr>
+        <a:xfrm>
+          <a:off x="0" y="0"/>
+          <a:ext cx="0" cy="0"/>
+          <a:chOff x="0" y="0"/>
+          <a:chExt cx="0" cy="0"/>
+        </a:xfrm>
+      </p:grpSpPr>
+      <p:sp>
+        <p:nvSpPr>
+          <p:cNvPr id="2" name="Slide Image Placeholder 1"/>
+          <p:cNvSpPr>
+            <a:spLocks noGrp="1" noRot="1" noChangeAspect="1"/>
+          </p:cNvSpPr>
+          <p:nvPr>
+            <p:ph type="sldImg"/>
+          </p:nvPr>
+        </p:nvSpPr>
+        <p:spPr/>
+      </p:sp>
+      <p:sp>
+        <p:nvSpPr>
+          <p:cNvPr id="3" name="Notes Placeholder 2"/>
+          <p:cNvSpPr>
+            <a:spLocks noGrp="1"/>
+          </p:cNvSpPr>
+          <p:nvPr>
+            <p:ph type="body" idx="1"/>
+          </p:nvPr>
+        </p:nvSpPr>
+        <p:spPr/>
+        <p:txBody>
+          <a:bodyPr/>
+          <a:lstStyle/>
+          <a:p>
+            <a:r>
+              <a:rPr lang="en-US" dirty="0"/>
+              <a:t/>
+            </a:r>
+            <a:endParaRPr lang="en-US" dirty="0"/>
+          </a:p>
+        </p:txBody>
+      </p:sp>
+      <p:sp>
+        <p:nvSpPr>
+          <p:cNvPr id="4" name="Slide Number Placeholder 3"/>
+          <p:cNvSpPr>
+            <a:spLocks noGrp="1"/>
+          </p:cNvSpPr>
+          <p:nvPr>
+            <p:ph type="sldNum" sz="quarter" idx="10"/>
+          </p:nvPr>
+        </p:nvSpPr>
+        <p:spPr/>
+        <p:txBody>
+          <a:bodyPr/>
+          <a:lstStyle/>
+          <a:p>
+            <a:fld id="{F7021451-1387-4CA6-816F-3879F97B5CBC}" type="slidenum">
+              <a:rPr lang="en-US"/>
+              <a:t>28</a:t>
+            </a:fld>
+            <a:endParaRPr lang="en-US"/>
+          </a:p>
+        </p:txBody>
+      </p:sp>
+    </p:spTree>
+    <p:extLst>
+      <p:ext uri="{BB962C8B-B14F-4D97-AF65-F5344CB8AC3E}">
+        <p14:creationId xmlns:p14="http://schemas.microsoft.com/office/powerpoint/2010/main" val="1024086991"/>
+      </p:ext>
+    </p:extLst>
+  </p:cSld>
+  <p:clrMapOvr>
+    <a:masterClrMapping/>
+  </p:clrMapOvr>
+</p:notes>
+</file>
+
+<file path=ppt/notesSlides/notesSlide29.xml><?xml version="1.0" encoding="utf-8"?>
+<p:notes xmlns:a="http://schemas.openxmlformats.org/drawingml/2006/main" xmlns:r="http://schemas.openxmlformats.org/officeDocument/2006/relationships" xmlns:p="http://schemas.openxmlformats.org/presentationml/2006/main">
+  <p:cSld>
+    <p:spTree>
+      <p:nvGrpSpPr>
+        <p:cNvPr id="1" name=""/>
+        <p:cNvGrpSpPr/>
+        <p:nvPr/>
+      </p:nvGrpSpPr>
+      <p:grpSpPr>
+        <a:xfrm>
+          <a:off x="0" y="0"/>
+          <a:ext cx="0" cy="0"/>
+          <a:chOff x="0" y="0"/>
+          <a:chExt cx="0" cy="0"/>
+        </a:xfrm>
+      </p:grpSpPr>
+      <p:sp>
+        <p:nvSpPr>
+          <p:cNvPr id="2" name="Slide Image Placeholder 1"/>
+          <p:cNvSpPr>
+            <a:spLocks noGrp="1" noRot="1" noChangeAspect="1"/>
+          </p:cNvSpPr>
+          <p:nvPr>
+            <p:ph type="sldImg"/>
+          </p:nvPr>
+        </p:nvSpPr>
+        <p:spPr/>
+      </p:sp>
+      <p:sp>
+        <p:nvSpPr>
+          <p:cNvPr id="3" name="Notes Placeholder 2"/>
+          <p:cNvSpPr>
+            <a:spLocks noGrp="1"/>
+          </p:cNvSpPr>
+          <p:nvPr>
+            <p:ph type="body" idx="1"/>
+          </p:nvPr>
+        </p:nvSpPr>
+        <p:spPr/>
+        <p:txBody>
+          <a:bodyPr/>
+          <a:lstStyle/>
+          <a:p>
+            <a:r>
+              <a:rPr lang="en-US" dirty="0"/>
+              <a:t/>
+            </a:r>
+            <a:endParaRPr lang="en-US" dirty="0"/>
+          </a:p>
+        </p:txBody>
+      </p:sp>
+      <p:sp>
+        <p:nvSpPr>
+          <p:cNvPr id="4" name="Slide Number Placeholder 3"/>
+          <p:cNvSpPr>
+            <a:spLocks noGrp="1"/>
+          </p:cNvSpPr>
+          <p:nvPr>
+            <p:ph type="sldNum" sz="quarter" idx="10"/>
+          </p:nvPr>
+        </p:nvSpPr>
+        <p:spPr/>
+        <p:txBody>
+          <a:bodyPr/>
+          <a:lstStyle/>
+          <a:p>
+            <a:fld id="{F7021451-1387-4CA6-816F-3879F97B5CBC}" type="slidenum">
+              <a:rPr lang="en-US"/>
+              <a:t>29</a:t>
+            </a:fld>
+            <a:endParaRPr lang="en-US"/>
+          </a:p>
+        </p:txBody>
+      </p:sp>
+    </p:spTree>
+    <p:extLst>
+      <p:ext uri="{BB962C8B-B14F-4D97-AF65-F5344CB8AC3E}">
+        <p14:creationId xmlns:p14="http://schemas.microsoft.com/office/powerpoint/2010/main" val="1024086991"/>
+      </p:ext>
+    </p:extLst>
+  </p:cSld>
+  <p:clrMapOvr>
+    <a:masterClrMapping/>
+  </p:clrMapOvr>
+</p:notes>
+</file>
+
 <file path=ppt/notesSlides/notesSlide3.xml><?xml version="1.0" encoding="utf-8"?>
 <p:notes xmlns:a="http://schemas.openxmlformats.org/drawingml/2006/main" xmlns:r="http://schemas.openxmlformats.org/officeDocument/2006/relationships" xmlns:p="http://schemas.openxmlformats.org/presentationml/2006/main">
   <p:cSld>
@@ -1778,6 +2491,94 @@
             <a:fld id="{F7021451-1387-4CA6-816F-3879F97B5CBC}" type="slidenum">
               <a:rPr lang="en-US"/>
               <a:t>3</a:t>
+            </a:fld>
+            <a:endParaRPr lang="en-US"/>
+          </a:p>
+        </p:txBody>
+      </p:sp>
+    </p:spTree>
+    <p:extLst>
+      <p:ext uri="{BB962C8B-B14F-4D97-AF65-F5344CB8AC3E}">
+        <p14:creationId xmlns:p14="http://schemas.microsoft.com/office/powerpoint/2010/main" val="1024086991"/>
+      </p:ext>
+    </p:extLst>
+  </p:cSld>
+  <p:clrMapOvr>
+    <a:masterClrMapping/>
+  </p:clrMapOvr>
+</p:notes>
+</file>
+
+<file path=ppt/notesSlides/notesSlide30.xml><?xml version="1.0" encoding="utf-8"?>
+<p:notes xmlns:a="http://schemas.openxmlformats.org/drawingml/2006/main" xmlns:r="http://schemas.openxmlformats.org/officeDocument/2006/relationships" xmlns:p="http://schemas.openxmlformats.org/presentationml/2006/main">
+  <p:cSld>
+    <p:spTree>
+      <p:nvGrpSpPr>
+        <p:cNvPr id="1" name=""/>
+        <p:cNvGrpSpPr/>
+        <p:nvPr/>
+      </p:nvGrpSpPr>
+      <p:grpSpPr>
+        <a:xfrm>
+          <a:off x="0" y="0"/>
+          <a:ext cx="0" cy="0"/>
+          <a:chOff x="0" y="0"/>
+          <a:chExt cx="0" cy="0"/>
+        </a:xfrm>
+      </p:grpSpPr>
+      <p:sp>
+        <p:nvSpPr>
+          <p:cNvPr id="2" name="Slide Image Placeholder 1"/>
+          <p:cNvSpPr>
+            <a:spLocks noGrp="1" noRot="1" noChangeAspect="1"/>
+          </p:cNvSpPr>
+          <p:nvPr>
+            <p:ph type="sldImg"/>
+          </p:nvPr>
+        </p:nvSpPr>
+        <p:spPr/>
+      </p:sp>
+      <p:sp>
+        <p:nvSpPr>
+          <p:cNvPr id="3" name="Notes Placeholder 2"/>
+          <p:cNvSpPr>
+            <a:spLocks noGrp="1"/>
+          </p:cNvSpPr>
+          <p:nvPr>
+            <p:ph type="body" idx="1"/>
+          </p:nvPr>
+        </p:nvSpPr>
+        <p:spPr/>
+        <p:txBody>
+          <a:bodyPr/>
+          <a:lstStyle/>
+          <a:p>
+            <a:r>
+              <a:rPr lang="en-US" dirty="0"/>
+              <a:t/>
+            </a:r>
+            <a:endParaRPr lang="en-US" dirty="0"/>
+          </a:p>
+        </p:txBody>
+      </p:sp>
+      <p:sp>
+        <p:nvSpPr>
+          <p:cNvPr id="4" name="Slide Number Placeholder 3"/>
+          <p:cNvSpPr>
+            <a:spLocks noGrp="1"/>
+          </p:cNvSpPr>
+          <p:nvPr>
+            <p:ph type="sldNum" sz="quarter" idx="10"/>
+          </p:nvPr>
+        </p:nvSpPr>
+        <p:spPr/>
+        <p:txBody>
+          <a:bodyPr/>
+          <a:lstStyle/>
+          <a:p>
+            <a:fld id="{F7021451-1387-4CA6-816F-3879F97B5CBC}" type="slidenum">
+              <a:rPr lang="en-US"/>
+              <a:t>30</a:t>
             </a:fld>
             <a:endParaRPr lang="en-US"/>
           </a:p>
@@ -2727,7 +3528,7 @@
                 <a:ea typeface="Cambria" pitchFamily="34" charset="-122"/>
                 <a:cs typeface="Cambria" pitchFamily="34" charset="-120"/>
               </a:rPr>
-              <a:t>Market Failure: Key Definitions</a:t>
+              <a:t>Market Failure: Definitions, Causes &amp; Consequences</a:t>
             </a:r>
             <a:endParaRPr lang="en-US" sz="4400" dirty="0"/>
           </a:p>
@@ -2766,7 +3567,7 @@
                 <a:ea typeface="Calibri" pitchFamily="34" charset="-122"/>
                 <a:cs typeface="Calibri" pitchFamily="34" charset="-120"/>
               </a:rPr>
-              <a:t>Two things we left hanging, finally named properly.</a:t>
+              <a:t>Two things we left hanging, finally named properly — and what they actually cause.</a:t>
             </a:r>
             <a:endParaRPr lang="en-US" sz="1800" dirty="0"/>
           </a:p>
@@ -4923,7 +5724,7 @@
                 <a:ea typeface="Cambria" pitchFamily="34" charset="-122"/>
                 <a:cs typeface="Cambria" pitchFamily="34" charset="-120"/>
               </a:rPr>
-              <a:t>Quick check</a:t>
+              <a:t>Quick check: definitions</a:t>
             </a:r>
             <a:endParaRPr lang="en-US" sz="3200" dirty="0"/>
           </a:p>
@@ -5201,7 +6002,7 @@
                 <a:ea typeface="Cambria" pitchFamily="34" charset="-122"/>
                 <a:cs typeface="Cambria" pitchFamily="34" charset="-120"/>
               </a:rPr>
-              <a:t>Recap</a:t>
+              <a:t>So what actually happens?</a:t>
             </a:r>
             <a:endParaRPr lang="en-US" sz="3200" dirty="0"/>
           </a:p>
@@ -5246,7 +6047,7 @@
                 <a:ea typeface="Calibri" pitchFamily="34" charset="-122"/>
                 <a:cs typeface="Calibri" pitchFamily="34" charset="-120"/>
               </a:rPr>
-              <a:t>Market failure: the price mechanism misallocates resources.</a:t>
+              <a:t>Naming a problem isn't the same as knowing its effect.</a:t>
             </a:r>
             <a:endParaRPr lang="en-US" sz="1800" dirty="0"/>
           </a:p>
@@ -5269,53 +6070,7 @@
                 <a:ea typeface="Calibri" pitchFamily="34" charset="-122"/>
                 <a:cs typeface="Calibri" pitchFamily="34" charset="-120"/>
               </a:rPr>
-              <a:t>Externalities: four types, split by production/consumption and negative/positive.</a:t>
-            </a:r>
-            <a:endParaRPr lang="en-US" sz="1800" dirty="0"/>
-          </a:p>
-          <a:p>
-            <a:pPr indent="0" marL="0">
-              <a:lnSpc>
-                <a:spcPct val="130000"/>
-              </a:lnSpc>
-              <a:spcAft>
-                <a:spcPts val="1400"/>
-              </a:spcAft>
-              <a:buNone/>
-            </a:pPr>
-            <a:r>
-              <a:rPr lang="en-US" sz="1800" dirty="0">
-                <a:solidFill>
-                  <a:srgbClr val="1A1A1A"/>
-                </a:solidFill>
-                <a:latin typeface="Calibri" pitchFamily="34" charset="0"/>
-                <a:ea typeface="Calibri" pitchFamily="34" charset="-122"/>
-                <a:cs typeface="Calibri" pitchFamily="34" charset="-120"/>
-              </a:rPr>
-              <a:t>Public goods: non-excludable + non-rivalrous → free-riding → the market under-supplies them.</a:t>
-            </a:r>
-            <a:endParaRPr lang="en-US" sz="1800" dirty="0"/>
-          </a:p>
-          <a:p>
-            <a:pPr indent="0" marL="0">
-              <a:lnSpc>
-                <a:spcPct val="130000"/>
-              </a:lnSpc>
-              <a:spcAft>
-                <a:spcPts val="1400"/>
-              </a:spcAft>
-              <a:buNone/>
-            </a:pPr>
-            <a:r>
-              <a:rPr lang="en-US" sz="1800" dirty="0">
-                <a:solidFill>
-                  <a:srgbClr val="1A1A1A"/>
-                </a:solidFill>
-                <a:latin typeface="Calibri" pitchFamily="34" charset="0"/>
-                <a:ea typeface="Calibri" pitchFamily="34" charset="-122"/>
-                <a:cs typeface="Calibri" pitchFamily="34" charset="-120"/>
-              </a:rPr>
-              <a:t>Merit goods under-provided, demerit goods over-provided — people misjudge the true benefit or cost.</a:t>
+              <a:t>Today: exactly what goes wrong with the amount produced, who gets affected, and a first look at government's response.</a:t>
             </a:r>
             <a:endParaRPr lang="en-US" sz="1800" dirty="0"/>
           </a:p>
@@ -5335,7 +6090,7 @@
     <p:bg>
       <p:bgPr>
         <a:solidFill>
-          <a:srgbClr val="1E2761"/>
+          <a:srgbClr val="FFFFFF"/>
         </a:solidFill>
       </p:bgPr>
     </p:bg>
@@ -5361,8 +6116,8 @@
         </p:nvSpPr>
         <p:spPr>
           <a:xfrm>
-            <a:off x="640080" y="2103120"/>
-            <a:ext cx="10881360" cy="457200"/>
+            <a:off x="640080" y="502920"/>
+            <a:ext cx="10881360" cy="731520"/>
           </a:xfrm>
           <a:prstGeom prst="rect">
             <a:avLst/>
@@ -5378,58 +6133,41 @@
               <a:buNone/>
             </a:pPr>
             <a:r>
-              <a:rPr lang="en-US" sz="1400" b="1" spc="200" kern="0" dirty="0">
-                <a:solidFill>
-                  <a:srgbClr val="CADCFC"/>
-                </a:solidFill>
-                <a:latin typeface="Calibri" pitchFamily="34" charset="0"/>
-                <a:ea typeface="Calibri" pitchFamily="34" charset="-122"/>
-                <a:cs typeface="Calibri" pitchFamily="34" charset="-120"/>
-              </a:rPr>
-              <a:t>NEXT LESSON</a:t>
-            </a:r>
-            <a:endParaRPr lang="en-US" sz="1400" dirty="0"/>
-          </a:p>
-        </p:txBody>
-      </p:sp>
-      <p:sp>
-        <p:nvSpPr>
-          <p:cNvPr id="3" name="Text 1"/>
-          <p:cNvSpPr/>
-          <p:nvPr/>
-        </p:nvSpPr>
-        <p:spPr>
-          <a:xfrm>
-            <a:off x="640080" y="2560320"/>
-            <a:ext cx="10881360" cy="1463040"/>
-          </a:xfrm>
-          <a:prstGeom prst="rect">
-            <a:avLst/>
-          </a:prstGeom>
-          <a:noFill/>
-          <a:ln/>
-        </p:spPr>
-        <p:txBody>
-          <a:bodyPr wrap="square" rtlCol="0" anchor="ctr"/>
-          <a:lstStyle/>
-          <a:p>
-            <a:pPr indent="0" marL="0">
-              <a:buNone/>
-            </a:pPr>
-            <a:r>
-              <a:rPr lang="en-US" sz="4400" b="1" dirty="0">
-                <a:solidFill>
-                  <a:srgbClr val="FFFFFF"/>
+              <a:rPr lang="en-US" sz="3000" b="1" dirty="0">
+                <a:solidFill>
+                  <a:srgbClr val="1E2761"/>
                 </a:solidFill>
                 <a:latin typeface="Cambria" pitchFamily="34" charset="0"/>
                 <a:ea typeface="Cambria" pitchFamily="34" charset="-122"/>
                 <a:cs typeface="Cambria" pitchFamily="34" charset="-120"/>
               </a:rPr>
-              <a:t>Market failure: causes &amp; consequences</a:t>
-            </a:r>
-            <a:endParaRPr lang="en-US" sz="4400" dirty="0"/>
-          </a:p>
-        </p:txBody>
+              <a:t>Market output vs. socially efficient output</a:t>
+            </a:r>
+            <a:endParaRPr lang="en-US" sz="3000" dirty="0"/>
+          </a:p>
+        </p:txBody>
+      </p:sp>
+      <p:sp>
+        <p:nvSpPr>
+          <p:cNvPr id="3" name="Shape 1"/>
+          <p:cNvSpPr/>
+          <p:nvPr/>
+        </p:nvSpPr>
+        <p:spPr>
+          <a:xfrm>
+            <a:off x="640080" y="1554480"/>
+            <a:ext cx="5212080" cy="3931920"/>
+          </a:xfrm>
+          <a:prstGeom prst="roundRect">
+            <a:avLst>
+              <a:gd name="adj" fmla="val 2791"/>
+            </a:avLst>
+          </a:prstGeom>
+          <a:solidFill>
+            <a:srgbClr val="F4F5F7"/>
+          </a:solidFill>
+          <a:ln/>
+        </p:spPr>
       </p:sp>
       <p:sp>
         <p:nvSpPr>
@@ -5439,8 +6177,8 @@
         </p:nvSpPr>
         <p:spPr>
           <a:xfrm>
-            <a:off x="640080" y="3931920"/>
-            <a:ext cx="9601200" cy="731520"/>
+            <a:off x="914400" y="1783080"/>
+            <a:ext cx="4663440" cy="457200"/>
           </a:xfrm>
           <a:prstGeom prst="rect">
             <a:avLst/>
@@ -5456,15 +6194,1755 @@
               <a:buNone/>
             </a:pPr>
             <a:r>
+              <a:rPr lang="en-US" sz="1800" b="1" dirty="0">
+                <a:solidFill>
+                  <a:srgbClr val="F96167"/>
+                </a:solidFill>
+                <a:latin typeface="Calibri" pitchFamily="34" charset="0"/>
+                <a:ea typeface="Calibri" pitchFamily="34" charset="-122"/>
+                <a:cs typeface="Calibri" pitchFamily="34" charset="-120"/>
+              </a:rPr>
+              <a:t>Market output</a:t>
+            </a:r>
+            <a:endParaRPr lang="en-US" sz="1800" dirty="0"/>
+          </a:p>
+        </p:txBody>
+      </p:sp>
+      <p:sp>
+        <p:nvSpPr>
+          <p:cNvPr id="5" name="Text 3"/>
+          <p:cNvSpPr/>
+          <p:nvPr/>
+        </p:nvSpPr>
+        <p:spPr>
+          <a:xfrm>
+            <a:off x="914400" y="2286000"/>
+            <a:ext cx="4663440" cy="3017520"/>
+          </a:xfrm>
+          <a:prstGeom prst="rect">
+            <a:avLst/>
+          </a:prstGeom>
+          <a:noFill/>
+          <a:ln/>
+        </p:spPr>
+        <p:txBody>
+          <a:bodyPr wrap="square" rtlCol="0" anchor="t"/>
+          <a:lstStyle/>
+          <a:p>
+            <a:pPr indent="0" marL="0">
+              <a:lnSpc>
+                <a:spcPct val="130000"/>
+              </a:lnSpc>
+              <a:buNone/>
+            </a:pPr>
+            <a:r>
+              <a:rPr lang="en-US" sz="1500" dirty="0">
+                <a:solidFill>
+                  <a:srgbClr val="1A1A1A"/>
+                </a:solidFill>
+                <a:latin typeface="Calibri" pitchFamily="34" charset="0"/>
+                <a:ea typeface="Calibri" pitchFamily="34" charset="-122"/>
+                <a:cs typeface="Calibri" pitchFamily="34" charset="-120"/>
+              </a:rPr>
+              <a:t>How much actually gets produced.</a:t>
+            </a:r>
+            <a:endParaRPr lang="en-US" sz="1500" dirty="0"/>
+          </a:p>
+          <a:p>
+            <a:pPr indent="0" marL="0">
+              <a:lnSpc>
+                <a:spcPct val="130000"/>
+              </a:lnSpc>
+              <a:buNone/>
+            </a:pPr>
+            <a:endParaRPr lang="en-US" sz="1500" dirty="0"/>
+          </a:p>
+          <a:p>
+            <a:pPr indent="0" marL="0">
+              <a:lnSpc>
+                <a:spcPct val="130000"/>
+              </a:lnSpc>
+              <a:buNone/>
+            </a:pPr>
+            <a:r>
+              <a:rPr lang="en-US" sz="1500" dirty="0">
+                <a:solidFill>
+                  <a:srgbClr val="1A1A1A"/>
+                </a:solidFill>
+                <a:latin typeface="Calibri" pitchFamily="34" charset="0"/>
+                <a:ea typeface="Calibri" pitchFamily="34" charset="-122"/>
+                <a:cs typeface="Calibri" pitchFamily="34" charset="-120"/>
+              </a:rPr>
+              <a:t>Based on private cost and private benefit alone.</a:t>
+            </a:r>
+            <a:endParaRPr lang="en-US" sz="1500" dirty="0"/>
+          </a:p>
+        </p:txBody>
+      </p:sp>
+      <p:sp>
+        <p:nvSpPr>
+          <p:cNvPr id="6" name="Shape 4"/>
+          <p:cNvSpPr/>
+          <p:nvPr/>
+        </p:nvSpPr>
+        <p:spPr>
+          <a:xfrm>
+            <a:off x="6126480" y="1554480"/>
+            <a:ext cx="5212080" cy="3931920"/>
+          </a:xfrm>
+          <a:prstGeom prst="roundRect">
+            <a:avLst>
+              <a:gd name="adj" fmla="val 2791"/>
+            </a:avLst>
+          </a:prstGeom>
+          <a:solidFill>
+            <a:srgbClr val="F4F5F7"/>
+          </a:solidFill>
+          <a:ln/>
+        </p:spPr>
+      </p:sp>
+      <p:sp>
+        <p:nvSpPr>
+          <p:cNvPr id="7" name="Text 5"/>
+          <p:cNvSpPr/>
+          <p:nvPr/>
+        </p:nvSpPr>
+        <p:spPr>
+          <a:xfrm>
+            <a:off x="6400800" y="1783080"/>
+            <a:ext cx="4663440" cy="457200"/>
+          </a:xfrm>
+          <a:prstGeom prst="rect">
+            <a:avLst/>
+          </a:prstGeom>
+          <a:noFill/>
+          <a:ln/>
+        </p:spPr>
+        <p:txBody>
+          <a:bodyPr wrap="square" rtlCol="0" anchor="ctr"/>
+          <a:lstStyle/>
+          <a:p>
+            <a:pPr indent="0" marL="0">
+              <a:buNone/>
+            </a:pPr>
+            <a:r>
+              <a:rPr lang="en-US" sz="1800" b="1" dirty="0">
+                <a:solidFill>
+                  <a:srgbClr val="D98C00"/>
+                </a:solidFill>
+                <a:latin typeface="Calibri" pitchFamily="34" charset="0"/>
+                <a:ea typeface="Calibri" pitchFamily="34" charset="-122"/>
+                <a:cs typeface="Calibri" pitchFamily="34" charset="-120"/>
+              </a:rPr>
+              <a:t>Socially efficient output</a:t>
+            </a:r>
+            <a:endParaRPr lang="en-US" sz="1800" dirty="0"/>
+          </a:p>
+        </p:txBody>
+      </p:sp>
+      <p:sp>
+        <p:nvSpPr>
+          <p:cNvPr id="8" name="Text 6"/>
+          <p:cNvSpPr/>
+          <p:nvPr/>
+        </p:nvSpPr>
+        <p:spPr>
+          <a:xfrm>
+            <a:off x="6400800" y="2286000"/>
+            <a:ext cx="4663440" cy="3017520"/>
+          </a:xfrm>
+          <a:prstGeom prst="rect">
+            <a:avLst/>
+          </a:prstGeom>
+          <a:noFill/>
+          <a:ln/>
+        </p:spPr>
+        <p:txBody>
+          <a:bodyPr wrap="square" rtlCol="0" anchor="t"/>
+          <a:lstStyle/>
+          <a:p>
+            <a:pPr indent="0" marL="0">
+              <a:lnSpc>
+                <a:spcPct val="130000"/>
+              </a:lnSpc>
+              <a:buNone/>
+            </a:pPr>
+            <a:r>
+              <a:rPr lang="en-US" sz="1500" dirty="0">
+                <a:solidFill>
+                  <a:srgbClr val="1A1A1A"/>
+                </a:solidFill>
+                <a:latin typeface="Calibri" pitchFamily="34" charset="0"/>
+                <a:ea typeface="Calibri" pitchFamily="34" charset="-122"/>
+                <a:cs typeface="Calibri" pitchFamily="34" charset="-120"/>
+              </a:rPr>
+              <a:t>How much SHOULD get produced.</a:t>
+            </a:r>
+            <a:endParaRPr lang="en-US" sz="1500" dirty="0"/>
+          </a:p>
+          <a:p>
+            <a:pPr indent="0" marL="0">
+              <a:lnSpc>
+                <a:spcPct val="130000"/>
+              </a:lnSpc>
+              <a:buNone/>
+            </a:pPr>
+            <a:endParaRPr lang="en-US" sz="1500" dirty="0"/>
+          </a:p>
+          <a:p>
+            <a:pPr indent="0" marL="0">
+              <a:lnSpc>
+                <a:spcPct val="130000"/>
+              </a:lnSpc>
+              <a:buNone/>
+            </a:pPr>
+            <a:r>
+              <a:rPr lang="en-US" sz="1500" dirty="0">
+                <a:solidFill>
+                  <a:srgbClr val="1A1A1A"/>
+                </a:solidFill>
+                <a:latin typeface="Calibri" pitchFamily="34" charset="0"/>
+                <a:ea typeface="Calibri" pitchFamily="34" charset="-122"/>
+                <a:cs typeface="Calibri" pitchFamily="34" charset="-120"/>
+              </a:rPr>
+              <a:t>Based on social cost and social benefit — the true cost/benefit to everyone.</a:t>
+            </a:r>
+            <a:endParaRPr lang="en-US" sz="1500" dirty="0"/>
+          </a:p>
+        </p:txBody>
+      </p:sp>
+    </p:spTree>
+  </p:cSld>
+  <p:clrMapOvr>
+    <a:masterClrMapping/>
+  </p:clrMapOvr>
+</p:sld>
+</file>
+
+<file path=ppt/slides/slide22.xml><?xml version="1.0" encoding="utf-8"?>
+<p:sld xmlns:a="http://schemas.openxmlformats.org/drawingml/2006/main" xmlns:r="http://schemas.openxmlformats.org/officeDocument/2006/relationships" xmlns:p="http://schemas.openxmlformats.org/presentationml/2006/main">
+  <p:cSld name="Slide 22">
+    <p:bg>
+      <p:bgPr>
+        <a:solidFill>
+          <a:srgbClr val="FFFFFF"/>
+        </a:solidFill>
+      </p:bgPr>
+    </p:bg>
+    <p:spTree>
+      <p:nvGrpSpPr>
+        <p:cNvPr id="1" name=""/>
+        <p:cNvGrpSpPr/>
+        <p:nvPr/>
+      </p:nvGrpSpPr>
+      <p:grpSpPr>
+        <a:xfrm>
+          <a:off x="0" y="0"/>
+          <a:ext cx="0" cy="0"/>
+          <a:chOff x="0" y="0"/>
+          <a:chExt cx="0" cy="0"/>
+        </a:xfrm>
+      </p:grpSpPr>
+      <p:sp>
+        <p:nvSpPr>
+          <p:cNvPr id="2" name="Text 0"/>
+          <p:cNvSpPr/>
+          <p:nvPr/>
+        </p:nvSpPr>
+        <p:spPr>
+          <a:xfrm>
+            <a:off x="640080" y="548640"/>
+            <a:ext cx="10881360" cy="822960"/>
+          </a:xfrm>
+          <a:prstGeom prst="rect">
+            <a:avLst/>
+          </a:prstGeom>
+          <a:noFill/>
+          <a:ln/>
+        </p:spPr>
+        <p:txBody>
+          <a:bodyPr wrap="square" rtlCol="0" anchor="ctr"/>
+          <a:lstStyle/>
+          <a:p>
+            <a:pPr indent="0" marL="0">
+              <a:buNone/>
+            </a:pPr>
+            <a:r>
+              <a:rPr lang="en-US" sz="3200" b="1" dirty="0">
+                <a:solidFill>
+                  <a:srgbClr val="1E2761"/>
+                </a:solidFill>
+                <a:latin typeface="Cambria" pitchFamily="34" charset="0"/>
+                <a:ea typeface="Cambria" pitchFamily="34" charset="-122"/>
+                <a:cs typeface="Cambria" pitchFamily="34" charset="-120"/>
+              </a:rPr>
+              <a:t>Negative externalities → overproduction</a:t>
+            </a:r>
+            <a:endParaRPr lang="en-US" sz="3200" dirty="0"/>
+          </a:p>
+        </p:txBody>
+      </p:sp>
+      <p:sp>
+        <p:nvSpPr>
+          <p:cNvPr id="3" name="Text 1"/>
+          <p:cNvSpPr/>
+          <p:nvPr/>
+        </p:nvSpPr>
+        <p:spPr>
+          <a:xfrm>
+            <a:off x="822960" y="1828800"/>
+            <a:ext cx="9875520" cy="4114800"/>
+          </a:xfrm>
+          <a:prstGeom prst="rect">
+            <a:avLst/>
+          </a:prstGeom>
+          <a:noFill/>
+          <a:ln/>
+        </p:spPr>
+        <p:txBody>
+          <a:bodyPr wrap="square" rtlCol="0" anchor="t"/>
+          <a:lstStyle/>
+          <a:p>
+            <a:pPr indent="0" marL="0">
+              <a:lnSpc>
+                <a:spcPct val="130000"/>
+              </a:lnSpc>
+              <a:spcAft>
+                <a:spcPts val="1400"/>
+              </a:spcAft>
+              <a:buNone/>
+            </a:pPr>
+            <a:r>
               <a:rPr lang="en-US" sz="1800" dirty="0">
                 <a:solidFill>
-                  <a:srgbClr val="CADCFC"/>
-                </a:solidFill>
-                <a:latin typeface="Calibri" pitchFamily="34" charset="0"/>
-                <a:ea typeface="Calibri" pitchFamily="34" charset="-122"/>
-                <a:cs typeface="Calibri" pitchFamily="34" charset="-120"/>
-              </a:rPr>
-              <a:t>What governments actually do about each of these problems.</a:t>
+                  <a:srgbClr val="1A1A1A"/>
+                </a:solidFill>
+                <a:latin typeface="Calibri" pitchFamily="34" charset="0"/>
+                <a:ea typeface="Calibri" pitchFamily="34" charset="-122"/>
+                <a:cs typeface="Calibri" pitchFamily="34" charset="-120"/>
+              </a:rPr>
+              <a:t>Tom's stream pollution: social cost is higher than private cost.</a:t>
+            </a:r>
+            <a:endParaRPr lang="en-US" sz="1800" dirty="0"/>
+          </a:p>
+          <a:p>
+            <a:pPr indent="0" marL="0">
+              <a:lnSpc>
+                <a:spcPct val="130000"/>
+              </a:lnSpc>
+              <a:spcAft>
+                <a:spcPts val="1400"/>
+              </a:spcAft>
+              <a:buNone/>
+            </a:pPr>
+            <a:r>
+              <a:rPr lang="en-US" sz="1800" dirty="0">
+                <a:solidFill>
+                  <a:srgbClr val="1A1A1A"/>
+                </a:solidFill>
+                <a:latin typeface="Calibri" pitchFamily="34" charset="0"/>
+                <a:ea typeface="Calibri" pitchFamily="34" charset="-122"/>
+                <a:cs typeface="Calibri" pitchFamily="34" charset="-120"/>
+              </a:rPr>
+              <a:t>The market only 'sees' private cost, so production keeps going past the point where it should stop.</a:t>
+            </a:r>
+            <a:endParaRPr lang="en-US" sz="1800" dirty="0"/>
+          </a:p>
+          <a:p>
+            <a:pPr indent="0" marL="0">
+              <a:lnSpc>
+                <a:spcPct val="130000"/>
+              </a:lnSpc>
+              <a:spcAft>
+                <a:spcPts val="1400"/>
+              </a:spcAft>
+              <a:buNone/>
+            </a:pPr>
+            <a:r>
+              <a:rPr lang="en-US" sz="1800" dirty="0">
+                <a:solidFill>
+                  <a:srgbClr val="1A1A1A"/>
+                </a:solidFill>
+                <a:latin typeface="Calibri" pitchFamily="34" charset="0"/>
+                <a:ea typeface="Calibri" pitchFamily="34" charset="-122"/>
+                <a:cs typeface="Calibri" pitchFamily="34" charset="-120"/>
+              </a:rPr>
+              <a:t>Result: MORE grips get produced than is actually best for society.</a:t>
+            </a:r>
+            <a:endParaRPr lang="en-US" sz="1800" dirty="0"/>
+          </a:p>
+        </p:txBody>
+      </p:sp>
+    </p:spTree>
+  </p:cSld>
+  <p:clrMapOvr>
+    <a:masterClrMapping/>
+  </p:clrMapOvr>
+</p:sld>
+</file>
+
+<file path=ppt/slides/slide23.xml><?xml version="1.0" encoding="utf-8"?>
+<p:sld xmlns:a="http://schemas.openxmlformats.org/drawingml/2006/main" xmlns:r="http://schemas.openxmlformats.org/officeDocument/2006/relationships" xmlns:p="http://schemas.openxmlformats.org/presentationml/2006/main">
+  <p:cSld name="Slide 23">
+    <p:bg>
+      <p:bgPr>
+        <a:solidFill>
+          <a:srgbClr val="FFFFFF"/>
+        </a:solidFill>
+      </p:bgPr>
+    </p:bg>
+    <p:spTree>
+      <p:nvGrpSpPr>
+        <p:cNvPr id="1" name=""/>
+        <p:cNvGrpSpPr/>
+        <p:nvPr/>
+      </p:nvGrpSpPr>
+      <p:grpSpPr>
+        <a:xfrm>
+          <a:off x="0" y="0"/>
+          <a:ext cx="0" cy="0"/>
+          <a:chOff x="0" y="0"/>
+          <a:chExt cx="0" cy="0"/>
+        </a:xfrm>
+      </p:grpSpPr>
+      <p:sp>
+        <p:nvSpPr>
+          <p:cNvPr id="2" name="Text 0"/>
+          <p:cNvSpPr/>
+          <p:nvPr/>
+        </p:nvSpPr>
+        <p:spPr>
+          <a:xfrm>
+            <a:off x="640080" y="548640"/>
+            <a:ext cx="10881360" cy="822960"/>
+          </a:xfrm>
+          <a:prstGeom prst="rect">
+            <a:avLst/>
+          </a:prstGeom>
+          <a:noFill/>
+          <a:ln/>
+        </p:spPr>
+        <p:txBody>
+          <a:bodyPr wrap="square" rtlCol="0" anchor="ctr"/>
+          <a:lstStyle/>
+          <a:p>
+            <a:pPr indent="0" marL="0">
+              <a:buNone/>
+            </a:pPr>
+            <a:r>
+              <a:rPr lang="en-US" sz="3200" b="1" dirty="0">
+                <a:solidFill>
+                  <a:srgbClr val="1E2761"/>
+                </a:solidFill>
+                <a:latin typeface="Cambria" pitchFamily="34" charset="0"/>
+                <a:ea typeface="Cambria" pitchFamily="34" charset="-122"/>
+                <a:cs typeface="Cambria" pitchFamily="34" charset="-120"/>
+              </a:rPr>
+              <a:t>Positive externalities &amp; merit goods → underproduction</a:t>
+            </a:r>
+            <a:endParaRPr lang="en-US" sz="3200" dirty="0"/>
+          </a:p>
+        </p:txBody>
+      </p:sp>
+      <p:sp>
+        <p:nvSpPr>
+          <p:cNvPr id="3" name="Text 1"/>
+          <p:cNvSpPr/>
+          <p:nvPr/>
+        </p:nvSpPr>
+        <p:spPr>
+          <a:xfrm>
+            <a:off x="822960" y="1828800"/>
+            <a:ext cx="9875520" cy="4114800"/>
+          </a:xfrm>
+          <a:prstGeom prst="rect">
+            <a:avLst/>
+          </a:prstGeom>
+          <a:noFill/>
+          <a:ln/>
+        </p:spPr>
+        <p:txBody>
+          <a:bodyPr wrap="square" rtlCol="0" anchor="t"/>
+          <a:lstStyle/>
+          <a:p>
+            <a:pPr indent="0" marL="0">
+              <a:lnSpc>
+                <a:spcPct val="130000"/>
+              </a:lnSpc>
+              <a:spcAft>
+                <a:spcPts val="1400"/>
+              </a:spcAft>
+              <a:buNone/>
+            </a:pPr>
+            <a:r>
+              <a:rPr lang="en-US" sz="1800" dirty="0">
+                <a:solidFill>
+                  <a:srgbClr val="1A1A1A"/>
+                </a:solidFill>
+                <a:latin typeface="Calibri" pitchFamily="34" charset="0"/>
+                <a:ea typeface="Calibri" pitchFamily="34" charset="-122"/>
+                <a:cs typeface="Calibri" pitchFamily="34" charset="-120"/>
+              </a:rPr>
+              <a:t>Tom's free coding workshop: social benefit is higher than private benefit.</a:t>
+            </a:r>
+            <a:endParaRPr lang="en-US" sz="1800" dirty="0"/>
+          </a:p>
+          <a:p>
+            <a:pPr indent="0" marL="0">
+              <a:lnSpc>
+                <a:spcPct val="130000"/>
+              </a:lnSpc>
+              <a:spcAft>
+                <a:spcPts val="1400"/>
+              </a:spcAft>
+              <a:buNone/>
+            </a:pPr>
+            <a:r>
+              <a:rPr lang="en-US" sz="1800" dirty="0">
+                <a:solidFill>
+                  <a:srgbClr val="1A1A1A"/>
+                </a:solidFill>
+                <a:latin typeface="Calibri" pitchFamily="34" charset="0"/>
+                <a:ea typeface="Calibri" pitchFamily="34" charset="-122"/>
+                <a:cs typeface="Calibri" pitchFamily="34" charset="-120"/>
+              </a:rPr>
+              <a:t>The market only 'sees' private benefit.</a:t>
+            </a:r>
+            <a:endParaRPr lang="en-US" sz="1800" dirty="0"/>
+          </a:p>
+          <a:p>
+            <a:pPr indent="0" marL="0">
+              <a:lnSpc>
+                <a:spcPct val="130000"/>
+              </a:lnSpc>
+              <a:spcAft>
+                <a:spcPts val="1400"/>
+              </a:spcAft>
+              <a:buNone/>
+            </a:pPr>
+            <a:r>
+              <a:rPr lang="en-US" sz="1800" dirty="0">
+                <a:solidFill>
+                  <a:srgbClr val="1A1A1A"/>
+                </a:solidFill>
+                <a:latin typeface="Calibri" pitchFamily="34" charset="0"/>
+                <a:ea typeface="Calibri" pitchFamily="34" charset="-122"/>
+                <a:cs typeface="Calibri" pitchFamily="34" charset="-120"/>
+              </a:rPr>
+              <a:t>Result: LESS of it gets provided than would actually be best for society.</a:t>
+            </a:r>
+            <a:endParaRPr lang="en-US" sz="1800" dirty="0"/>
+          </a:p>
+        </p:txBody>
+      </p:sp>
+    </p:spTree>
+  </p:cSld>
+  <p:clrMapOvr>
+    <a:masterClrMapping/>
+  </p:clrMapOvr>
+</p:sld>
+</file>
+
+<file path=ppt/slides/slide24.xml><?xml version="1.0" encoding="utf-8"?>
+<p:sld xmlns:a="http://schemas.openxmlformats.org/drawingml/2006/main" xmlns:r="http://schemas.openxmlformats.org/officeDocument/2006/relationships" xmlns:p="http://schemas.openxmlformats.org/presentationml/2006/main">
+  <p:cSld name="Slide 24">
+    <p:bg>
+      <p:bgPr>
+        <a:solidFill>
+          <a:srgbClr val="FFFFFF"/>
+        </a:solidFill>
+      </p:bgPr>
+    </p:bg>
+    <p:spTree>
+      <p:nvGrpSpPr>
+        <p:cNvPr id="1" name=""/>
+        <p:cNvGrpSpPr/>
+        <p:nvPr/>
+      </p:nvGrpSpPr>
+      <p:grpSpPr>
+        <a:xfrm>
+          <a:off x="0" y="0"/>
+          <a:ext cx="0" cy="0"/>
+          <a:chOff x="0" y="0"/>
+          <a:chExt cx="0" cy="0"/>
+        </a:xfrm>
+      </p:grpSpPr>
+      <p:sp>
+        <p:nvSpPr>
+          <p:cNvPr id="2" name="Text 0"/>
+          <p:cNvSpPr/>
+          <p:nvPr/>
+        </p:nvSpPr>
+        <p:spPr>
+          <a:xfrm>
+            <a:off x="640080" y="548640"/>
+            <a:ext cx="10881360" cy="822960"/>
+          </a:xfrm>
+          <a:prstGeom prst="rect">
+            <a:avLst/>
+          </a:prstGeom>
+          <a:noFill/>
+          <a:ln/>
+        </p:spPr>
+        <p:txBody>
+          <a:bodyPr wrap="square" rtlCol="0" anchor="ctr"/>
+          <a:lstStyle/>
+          <a:p>
+            <a:pPr indent="0" marL="0">
+              <a:buNone/>
+            </a:pPr>
+            <a:r>
+              <a:rPr lang="en-US" sz="3200" b="1" dirty="0">
+                <a:solidFill>
+                  <a:srgbClr val="1E2761"/>
+                </a:solidFill>
+                <a:latin typeface="Cambria" pitchFamily="34" charset="0"/>
+                <a:ea typeface="Cambria" pitchFamily="34" charset="-122"/>
+                <a:cs typeface="Cambria" pitchFamily="34" charset="-120"/>
+              </a:rPr>
+              <a:t>Public goods → zero provision</a:t>
+            </a:r>
+            <a:endParaRPr lang="en-US" sz="3200" dirty="0"/>
+          </a:p>
+        </p:txBody>
+      </p:sp>
+      <p:sp>
+        <p:nvSpPr>
+          <p:cNvPr id="3" name="Text 1"/>
+          <p:cNvSpPr/>
+          <p:nvPr/>
+        </p:nvSpPr>
+        <p:spPr>
+          <a:xfrm>
+            <a:off x="822960" y="1828800"/>
+            <a:ext cx="9875520" cy="4114800"/>
+          </a:xfrm>
+          <a:prstGeom prst="rect">
+            <a:avLst/>
+          </a:prstGeom>
+          <a:noFill/>
+          <a:ln/>
+        </p:spPr>
+        <p:txBody>
+          <a:bodyPr wrap="square" rtlCol="0" anchor="t"/>
+          <a:lstStyle/>
+          <a:p>
+            <a:pPr indent="0" marL="0">
+              <a:lnSpc>
+                <a:spcPct val="130000"/>
+              </a:lnSpc>
+              <a:spcAft>
+                <a:spcPts val="1400"/>
+              </a:spcAft>
+              <a:buNone/>
+            </a:pPr>
+            <a:r>
+              <a:rPr lang="en-US" sz="1800" dirty="0">
+                <a:solidFill>
+                  <a:srgbClr val="1A1A1A"/>
+                </a:solidFill>
+                <a:latin typeface="Calibri" pitchFamily="34" charset="0"/>
+                <a:ea typeface="Calibri" pitchFamily="34" charset="-122"/>
+                <a:cs typeface="Calibri" pitchFamily="34" charset="-120"/>
+              </a:rPr>
+              <a:t>The free-rider problem means a private firm can't capture profit from something like streetlights.</a:t>
+            </a:r>
+            <a:endParaRPr lang="en-US" sz="1800" dirty="0"/>
+          </a:p>
+          <a:p>
+            <a:pPr indent="0" marL="0">
+              <a:lnSpc>
+                <a:spcPct val="130000"/>
+              </a:lnSpc>
+              <a:spcAft>
+                <a:spcPts val="1400"/>
+              </a:spcAft>
+              <a:buNone/>
+            </a:pPr>
+            <a:r>
+              <a:rPr lang="en-US" sz="1800" dirty="0">
+                <a:solidFill>
+                  <a:srgbClr val="1A1A1A"/>
+                </a:solidFill>
+                <a:latin typeface="Calibri" pitchFamily="34" charset="0"/>
+                <a:ea typeface="Calibri" pitchFamily="34" charset="-122"/>
+                <a:cs typeface="Calibri" pitchFamily="34" charset="-120"/>
+              </a:rPr>
+              <a:t>Result: the market provides NONE at all, even though people clearly want it.</a:t>
+            </a:r>
+            <a:endParaRPr lang="en-US" sz="1800" dirty="0"/>
+          </a:p>
+        </p:txBody>
+      </p:sp>
+    </p:spTree>
+  </p:cSld>
+  <p:clrMapOvr>
+    <a:masterClrMapping/>
+  </p:clrMapOvr>
+</p:sld>
+</file>
+
+<file path=ppt/slides/slide25.xml><?xml version="1.0" encoding="utf-8"?>
+<p:sld xmlns:a="http://schemas.openxmlformats.org/drawingml/2006/main" xmlns:r="http://schemas.openxmlformats.org/officeDocument/2006/relationships" xmlns:p="http://schemas.openxmlformats.org/presentationml/2006/main">
+  <p:cSld name="Slide 25">
+    <p:bg>
+      <p:bgPr>
+        <a:solidFill>
+          <a:srgbClr val="FFFFFF"/>
+        </a:solidFill>
+      </p:bgPr>
+    </p:bg>
+    <p:spTree>
+      <p:nvGrpSpPr>
+        <p:cNvPr id="1" name=""/>
+        <p:cNvGrpSpPr/>
+        <p:nvPr/>
+      </p:nvGrpSpPr>
+      <p:grpSpPr>
+        <a:xfrm>
+          <a:off x="0" y="0"/>
+          <a:ext cx="0" cy="0"/>
+          <a:chOff x="0" y="0"/>
+          <a:chExt cx="0" cy="0"/>
+        </a:xfrm>
+      </p:grpSpPr>
+      <p:sp>
+        <p:nvSpPr>
+          <p:cNvPr id="2" name="Text 0"/>
+          <p:cNvSpPr/>
+          <p:nvPr/>
+        </p:nvSpPr>
+        <p:spPr>
+          <a:xfrm>
+            <a:off x="640080" y="548640"/>
+            <a:ext cx="10881360" cy="822960"/>
+          </a:xfrm>
+          <a:prstGeom prst="rect">
+            <a:avLst/>
+          </a:prstGeom>
+          <a:noFill/>
+          <a:ln/>
+        </p:spPr>
+        <p:txBody>
+          <a:bodyPr wrap="square" rtlCol="0" anchor="ctr"/>
+          <a:lstStyle/>
+          <a:p>
+            <a:pPr indent="0" marL="0">
+              <a:buNone/>
+            </a:pPr>
+            <a:r>
+              <a:rPr lang="en-US" sz="3200" b="1" dirty="0">
+                <a:solidFill>
+                  <a:srgbClr val="1E2761"/>
+                </a:solidFill>
+                <a:latin typeface="Cambria" pitchFamily="34" charset="0"/>
+                <a:ea typeface="Cambria" pitchFamily="34" charset="-122"/>
+                <a:cs typeface="Cambria" pitchFamily="34" charset="-120"/>
+              </a:rPr>
+              <a:t>Now you try: which consequence?</a:t>
+            </a:r>
+            <a:endParaRPr lang="en-US" sz="3200" dirty="0"/>
+          </a:p>
+        </p:txBody>
+      </p:sp>
+      <p:sp>
+        <p:nvSpPr>
+          <p:cNvPr id="3" name="Text 1"/>
+          <p:cNvSpPr/>
+          <p:nvPr/>
+        </p:nvSpPr>
+        <p:spPr>
+          <a:xfrm>
+            <a:off x="822960" y="1828800"/>
+            <a:ext cx="9875520" cy="4114800"/>
+          </a:xfrm>
+          <a:prstGeom prst="rect">
+            <a:avLst/>
+          </a:prstGeom>
+          <a:noFill/>
+          <a:ln/>
+        </p:spPr>
+        <p:txBody>
+          <a:bodyPr wrap="square" rtlCol="0" anchor="t"/>
+          <a:lstStyle/>
+          <a:p>
+            <a:pPr indent="0" marL="0">
+              <a:lnSpc>
+                <a:spcPct val="130000"/>
+              </a:lnSpc>
+              <a:spcAft>
+                <a:spcPts val="1400"/>
+              </a:spcAft>
+              <a:buNone/>
+            </a:pPr>
+            <a:r>
+              <a:rPr lang="en-US" sz="1800" dirty="0">
+                <a:solidFill>
+                  <a:srgbClr val="1A1A1A"/>
+                </a:solidFill>
+                <a:latin typeface="Calibri" pitchFamily="34" charset="0"/>
+                <a:ea typeface="Calibri" pitchFamily="34" charset="-122"/>
+                <a:cs typeface="Calibri" pitchFamily="34" charset="-120"/>
+              </a:rPr>
+              <a:t>Tom keeps printing extra grips even though the pollution cost is never paid by him.</a:t>
+            </a:r>
+            <a:endParaRPr lang="en-US" sz="1800" dirty="0"/>
+          </a:p>
+          <a:p>
+            <a:pPr indent="0" marL="0">
+              <a:lnSpc>
+                <a:spcPct val="130000"/>
+              </a:lnSpc>
+              <a:spcAft>
+                <a:spcPts val="1400"/>
+              </a:spcAft>
+              <a:buNone/>
+            </a:pPr>
+            <a:r>
+              <a:rPr lang="en-US" sz="1800" dirty="0">
+                <a:solidFill>
+                  <a:srgbClr val="1A1A1A"/>
+                </a:solidFill>
+                <a:latin typeface="Calibri" pitchFamily="34" charset="0"/>
+                <a:ea typeface="Calibri" pitchFamily="34" charset="-122"/>
+                <a:cs typeface="Calibri" pitchFamily="34" charset="-120"/>
+              </a:rPr>
+              <a:t>A free vaccination programme reaches fewer people than would benefit society.</a:t>
+            </a:r>
+            <a:endParaRPr lang="en-US" sz="1800" dirty="0"/>
+          </a:p>
+          <a:p>
+            <a:pPr indent="0" marL="0">
+              <a:lnSpc>
+                <a:spcPct val="130000"/>
+              </a:lnSpc>
+              <a:spcAft>
+                <a:spcPts val="1400"/>
+              </a:spcAft>
+              <a:buNone/>
+            </a:pPr>
+            <a:r>
+              <a:rPr lang="en-US" sz="1800" dirty="0">
+                <a:solidFill>
+                  <a:srgbClr val="1A1A1A"/>
+                </a:solidFill>
+                <a:latin typeface="Calibri" pitchFamily="34" charset="0"/>
+                <a:ea typeface="Calibri" pitchFamily="34" charset="-122"/>
+                <a:cs typeface="Calibri" pitchFamily="34" charset="-120"/>
+              </a:rPr>
+              <a:t>Nobody builds a lighthouse, because no single ship owner will pay for something every ship benefits from for free.</a:t>
+            </a:r>
+            <a:endParaRPr lang="en-US" sz="1800" dirty="0"/>
+          </a:p>
+        </p:txBody>
+      </p:sp>
+    </p:spTree>
+  </p:cSld>
+  <p:clrMapOvr>
+    <a:masterClrMapping/>
+  </p:clrMapOvr>
+</p:sld>
+</file>
+
+<file path=ppt/slides/slide26.xml><?xml version="1.0" encoding="utf-8"?>
+<p:sld xmlns:a="http://schemas.openxmlformats.org/drawingml/2006/main" xmlns:r="http://schemas.openxmlformats.org/officeDocument/2006/relationships" xmlns:p="http://schemas.openxmlformats.org/presentationml/2006/main">
+  <p:cSld name="Slide 26">
+    <p:bg>
+      <p:bgPr>
+        <a:solidFill>
+          <a:srgbClr val="FFFFFF"/>
+        </a:solidFill>
+      </p:bgPr>
+    </p:bg>
+    <p:spTree>
+      <p:nvGrpSpPr>
+        <p:cNvPr id="1" name=""/>
+        <p:cNvGrpSpPr/>
+        <p:nvPr/>
+      </p:nvGrpSpPr>
+      <p:grpSpPr>
+        <a:xfrm>
+          <a:off x="0" y="0"/>
+          <a:ext cx="0" cy="0"/>
+          <a:chOff x="0" y="0"/>
+          <a:chExt cx="0" cy="0"/>
+        </a:xfrm>
+      </p:grpSpPr>
+      <p:sp>
+        <p:nvSpPr>
+          <p:cNvPr id="2" name="Text 0"/>
+          <p:cNvSpPr/>
+          <p:nvPr/>
+        </p:nvSpPr>
+        <p:spPr>
+          <a:xfrm>
+            <a:off x="640080" y="548640"/>
+            <a:ext cx="10881360" cy="731520"/>
+          </a:xfrm>
+          <a:prstGeom prst="rect">
+            <a:avLst/>
+          </a:prstGeom>
+          <a:noFill/>
+          <a:ln/>
+        </p:spPr>
+        <p:txBody>
+          <a:bodyPr wrap="square" rtlCol="0" anchor="ctr"/>
+          <a:lstStyle/>
+          <a:p>
+            <a:pPr indent="0" marL="0">
+              <a:buNone/>
+            </a:pPr>
+            <a:r>
+              <a:rPr lang="en-US" sz="3000" b="1" dirty="0">
+                <a:solidFill>
+                  <a:srgbClr val="1E2761"/>
+                </a:solidFill>
+                <a:latin typeface="Cambria" pitchFamily="34" charset="0"/>
+                <a:ea typeface="Cambria" pitchFamily="34" charset="-122"/>
+                <a:cs typeface="Cambria" pitchFamily="34" charset="-120"/>
+              </a:rPr>
+              <a:t>Who bears the consequences?</a:t>
+            </a:r>
+            <a:endParaRPr lang="en-US" sz="3000" dirty="0"/>
+          </a:p>
+        </p:txBody>
+      </p:sp>
+      <p:sp>
+        <p:nvSpPr>
+          <p:cNvPr id="3" name="Shape 1"/>
+          <p:cNvSpPr/>
+          <p:nvPr/>
+        </p:nvSpPr>
+        <p:spPr>
+          <a:xfrm>
+            <a:off x="790956" y="1828800"/>
+            <a:ext cx="3291840" cy="3108960"/>
+          </a:xfrm>
+          <a:prstGeom prst="roundRect">
+            <a:avLst>
+              <a:gd name="adj" fmla="val 3529"/>
+            </a:avLst>
+          </a:prstGeom>
+          <a:solidFill>
+            <a:srgbClr val="F4F5F7"/>
+          </a:solidFill>
+          <a:ln/>
+        </p:spPr>
+      </p:sp>
+      <p:sp>
+        <p:nvSpPr>
+          <p:cNvPr id="4" name="Text 2"/>
+          <p:cNvSpPr/>
+          <p:nvPr/>
+        </p:nvSpPr>
+        <p:spPr>
+          <a:xfrm>
+            <a:off x="1065276" y="2103120"/>
+            <a:ext cx="2743200" cy="548640"/>
+          </a:xfrm>
+          <a:prstGeom prst="rect">
+            <a:avLst/>
+          </a:prstGeom>
+          <a:noFill/>
+          <a:ln/>
+        </p:spPr>
+        <p:txBody>
+          <a:bodyPr wrap="square" rtlCol="0" anchor="ctr"/>
+          <a:lstStyle/>
+          <a:p>
+            <a:pPr indent="0" marL="0">
+              <a:buNone/>
+            </a:pPr>
+            <a:r>
+              <a:rPr lang="en-US" sz="1600" b="1" dirty="0">
+                <a:solidFill>
+                  <a:srgbClr val="1E2761"/>
+                </a:solidFill>
+                <a:latin typeface="Calibri" pitchFamily="34" charset="0"/>
+                <a:ea typeface="Calibri" pitchFamily="34" charset="-122"/>
+                <a:cs typeface="Calibri" pitchFamily="34" charset="-120"/>
+              </a:rPr>
+              <a:t>Consumers</a:t>
+            </a:r>
+            <a:endParaRPr lang="en-US" sz="1600" dirty="0"/>
+          </a:p>
+        </p:txBody>
+      </p:sp>
+      <p:sp>
+        <p:nvSpPr>
+          <p:cNvPr id="5" name="Text 3"/>
+          <p:cNvSpPr/>
+          <p:nvPr/>
+        </p:nvSpPr>
+        <p:spPr>
+          <a:xfrm>
+            <a:off x="1065276" y="2697480"/>
+            <a:ext cx="2743200" cy="2011680"/>
+          </a:xfrm>
+          <a:prstGeom prst="rect">
+            <a:avLst/>
+          </a:prstGeom>
+          <a:noFill/>
+          <a:ln/>
+        </p:spPr>
+        <p:txBody>
+          <a:bodyPr wrap="square" rtlCol="0" anchor="t"/>
+          <a:lstStyle/>
+          <a:p>
+            <a:pPr indent="0" marL="0">
+              <a:lnSpc>
+                <a:spcPct val="125000"/>
+              </a:lnSpc>
+              <a:buNone/>
+            </a:pPr>
+            <a:r>
+              <a:rPr lang="en-US" sz="1250" dirty="0">
+                <a:solidFill>
+                  <a:srgbClr val="1A1A1A"/>
+                </a:solidFill>
+                <a:latin typeface="Calibri" pitchFamily="34" charset="0"/>
+                <a:ea typeface="Calibri" pitchFamily="34" charset="-122"/>
+                <a:cs typeface="Calibri" pitchFamily="34" charset="-120"/>
+              </a:rPr>
+              <a:t>May pay for goods that quietly harm others, or miss out on merit goods that would genuinely benefit them.</a:t>
+            </a:r>
+            <a:endParaRPr lang="en-US" sz="1250" dirty="0"/>
+          </a:p>
+        </p:txBody>
+      </p:sp>
+      <p:sp>
+        <p:nvSpPr>
+          <p:cNvPr id="6" name="Shape 4"/>
+          <p:cNvSpPr/>
+          <p:nvPr/>
+        </p:nvSpPr>
+        <p:spPr>
+          <a:xfrm>
+            <a:off x="4448556" y="1828800"/>
+            <a:ext cx="3291840" cy="3108960"/>
+          </a:xfrm>
+          <a:prstGeom prst="roundRect">
+            <a:avLst>
+              <a:gd name="adj" fmla="val 3529"/>
+            </a:avLst>
+          </a:prstGeom>
+          <a:solidFill>
+            <a:srgbClr val="F4F5F7"/>
+          </a:solidFill>
+          <a:ln/>
+        </p:spPr>
+      </p:sp>
+      <p:sp>
+        <p:nvSpPr>
+          <p:cNvPr id="7" name="Text 5"/>
+          <p:cNvSpPr/>
+          <p:nvPr/>
+        </p:nvSpPr>
+        <p:spPr>
+          <a:xfrm>
+            <a:off x="4722876" y="2103120"/>
+            <a:ext cx="2743200" cy="548640"/>
+          </a:xfrm>
+          <a:prstGeom prst="rect">
+            <a:avLst/>
+          </a:prstGeom>
+          <a:noFill/>
+          <a:ln/>
+        </p:spPr>
+        <p:txBody>
+          <a:bodyPr wrap="square" rtlCol="0" anchor="ctr"/>
+          <a:lstStyle/>
+          <a:p>
+            <a:pPr indent="0" marL="0">
+              <a:buNone/>
+            </a:pPr>
+            <a:r>
+              <a:rPr lang="en-US" sz="1600" b="1" dirty="0">
+                <a:solidFill>
+                  <a:srgbClr val="1E2761"/>
+                </a:solidFill>
+                <a:latin typeface="Calibri" pitchFamily="34" charset="0"/>
+                <a:ea typeface="Calibri" pitchFamily="34" charset="-122"/>
+                <a:cs typeface="Calibri" pitchFamily="34" charset="-120"/>
+              </a:rPr>
+              <a:t>Producers</a:t>
+            </a:r>
+            <a:endParaRPr lang="en-US" sz="1600" dirty="0"/>
+          </a:p>
+        </p:txBody>
+      </p:sp>
+      <p:sp>
+        <p:nvSpPr>
+          <p:cNvPr id="8" name="Text 6"/>
+          <p:cNvSpPr/>
+          <p:nvPr/>
+        </p:nvSpPr>
+        <p:spPr>
+          <a:xfrm>
+            <a:off x="4722876" y="2697480"/>
+            <a:ext cx="2743200" cy="2011680"/>
+          </a:xfrm>
+          <a:prstGeom prst="rect">
+            <a:avLst/>
+          </a:prstGeom>
+          <a:noFill/>
+          <a:ln/>
+        </p:spPr>
+        <p:txBody>
+          <a:bodyPr wrap="square" rtlCol="0" anchor="t"/>
+          <a:lstStyle/>
+          <a:p>
+            <a:pPr indent="0" marL="0">
+              <a:lnSpc>
+                <a:spcPct val="125000"/>
+              </a:lnSpc>
+              <a:buNone/>
+            </a:pPr>
+            <a:r>
+              <a:rPr lang="en-US" sz="1250" dirty="0">
+                <a:solidFill>
+                  <a:srgbClr val="1A1A1A"/>
+                </a:solidFill>
+                <a:latin typeface="Calibri" pitchFamily="34" charset="0"/>
+                <a:ea typeface="Calibri" pitchFamily="34" charset="-122"/>
+                <a:cs typeface="Calibri" pitchFamily="34" charset="-120"/>
+              </a:rPr>
+              <a:t>No market signal to change — nobody's actually charging them for the externality they create.</a:t>
+            </a:r>
+            <a:endParaRPr lang="en-US" sz="1250" dirty="0"/>
+          </a:p>
+        </p:txBody>
+      </p:sp>
+      <p:sp>
+        <p:nvSpPr>
+          <p:cNvPr id="9" name="Shape 7"/>
+          <p:cNvSpPr/>
+          <p:nvPr/>
+        </p:nvSpPr>
+        <p:spPr>
+          <a:xfrm>
+            <a:off x="8106156" y="1828800"/>
+            <a:ext cx="3291840" cy="3108960"/>
+          </a:xfrm>
+          <a:prstGeom prst="roundRect">
+            <a:avLst>
+              <a:gd name="adj" fmla="val 3529"/>
+            </a:avLst>
+          </a:prstGeom>
+          <a:solidFill>
+            <a:srgbClr val="F4F5F7"/>
+          </a:solidFill>
+          <a:ln/>
+        </p:spPr>
+      </p:sp>
+      <p:sp>
+        <p:nvSpPr>
+          <p:cNvPr id="10" name="Text 8"/>
+          <p:cNvSpPr/>
+          <p:nvPr/>
+        </p:nvSpPr>
+        <p:spPr>
+          <a:xfrm>
+            <a:off x="8380476" y="2103120"/>
+            <a:ext cx="2743200" cy="548640"/>
+          </a:xfrm>
+          <a:prstGeom prst="rect">
+            <a:avLst/>
+          </a:prstGeom>
+          <a:noFill/>
+          <a:ln/>
+        </p:spPr>
+        <p:txBody>
+          <a:bodyPr wrap="square" rtlCol="0" anchor="ctr"/>
+          <a:lstStyle/>
+          <a:p>
+            <a:pPr indent="0" marL="0">
+              <a:buNone/>
+            </a:pPr>
+            <a:r>
+              <a:rPr lang="en-US" sz="1600" b="1" dirty="0">
+                <a:solidFill>
+                  <a:srgbClr val="1E2761"/>
+                </a:solidFill>
+                <a:latin typeface="Calibri" pitchFamily="34" charset="0"/>
+                <a:ea typeface="Calibri" pitchFamily="34" charset="-122"/>
+                <a:cs typeface="Calibri" pitchFamily="34" charset="-120"/>
+              </a:rPr>
+              <a:t>Government</a:t>
+            </a:r>
+            <a:endParaRPr lang="en-US" sz="1600" dirty="0"/>
+          </a:p>
+        </p:txBody>
+      </p:sp>
+      <p:sp>
+        <p:nvSpPr>
+          <p:cNvPr id="11" name="Text 9"/>
+          <p:cNvSpPr/>
+          <p:nvPr/>
+        </p:nvSpPr>
+        <p:spPr>
+          <a:xfrm>
+            <a:off x="8380476" y="2697480"/>
+            <a:ext cx="2743200" cy="2011680"/>
+          </a:xfrm>
+          <a:prstGeom prst="rect">
+            <a:avLst/>
+          </a:prstGeom>
+          <a:noFill/>
+          <a:ln/>
+        </p:spPr>
+        <p:txBody>
+          <a:bodyPr wrap="square" rtlCol="0" anchor="t"/>
+          <a:lstStyle/>
+          <a:p>
+            <a:pPr indent="0" marL="0">
+              <a:lnSpc>
+                <a:spcPct val="125000"/>
+              </a:lnSpc>
+              <a:buNone/>
+            </a:pPr>
+            <a:r>
+              <a:rPr lang="en-US" sz="1250" dirty="0">
+                <a:solidFill>
+                  <a:srgbClr val="1A1A1A"/>
+                </a:solidFill>
+                <a:latin typeface="Calibri" pitchFamily="34" charset="0"/>
+                <a:ea typeface="Calibri" pitchFamily="34" charset="-122"/>
+                <a:cs typeface="Calibri" pitchFamily="34" charset="-120"/>
+              </a:rPr>
+              <a:t>Must decide whether the gap is big enough to justify stepping in, and how.</a:t>
+            </a:r>
+            <a:endParaRPr lang="en-US" sz="1250" dirty="0"/>
+          </a:p>
+        </p:txBody>
+      </p:sp>
+    </p:spTree>
+  </p:cSld>
+  <p:clrMapOvr>
+    <a:masterClrMapping/>
+  </p:clrMapOvr>
+</p:sld>
+</file>
+
+<file path=ppt/slides/slide27.xml><?xml version="1.0" encoding="utf-8"?>
+<p:sld xmlns:a="http://schemas.openxmlformats.org/drawingml/2006/main" xmlns:r="http://schemas.openxmlformats.org/officeDocument/2006/relationships" xmlns:p="http://schemas.openxmlformats.org/presentationml/2006/main">
+  <p:cSld name="Slide 27">
+    <p:bg>
+      <p:bgPr>
+        <a:solidFill>
+          <a:srgbClr val="FFFFFF"/>
+        </a:solidFill>
+      </p:bgPr>
+    </p:bg>
+    <p:spTree>
+      <p:nvGrpSpPr>
+        <p:cNvPr id="1" name=""/>
+        <p:cNvGrpSpPr/>
+        <p:nvPr/>
+      </p:nvGrpSpPr>
+      <p:grpSpPr>
+        <a:xfrm>
+          <a:off x="0" y="0"/>
+          <a:ext cx="0" cy="0"/>
+          <a:chOff x="0" y="0"/>
+          <a:chExt cx="0" cy="0"/>
+        </a:xfrm>
+      </p:grpSpPr>
+      <p:sp>
+        <p:nvSpPr>
+          <p:cNvPr id="2" name="Text 0"/>
+          <p:cNvSpPr/>
+          <p:nvPr/>
+        </p:nvSpPr>
+        <p:spPr>
+          <a:xfrm>
+            <a:off x="640080" y="548640"/>
+            <a:ext cx="10881360" cy="822960"/>
+          </a:xfrm>
+          <a:prstGeom prst="rect">
+            <a:avLst/>
+          </a:prstGeom>
+          <a:noFill/>
+          <a:ln/>
+        </p:spPr>
+        <p:txBody>
+          <a:bodyPr wrap="square" rtlCol="0" anchor="ctr"/>
+          <a:lstStyle/>
+          <a:p>
+            <a:pPr indent="0" marL="0">
+              <a:buNone/>
+            </a:pPr>
+            <a:r>
+              <a:rPr lang="en-US" sz="3200" b="1" dirty="0">
+                <a:solidFill>
+                  <a:srgbClr val="1E2761"/>
+                </a:solidFill>
+                <a:latin typeface="Cambria" pitchFamily="34" charset="0"/>
+                <a:ea typeface="Cambria" pitchFamily="34" charset="-122"/>
+                <a:cs typeface="Cambria" pitchFamily="34" charset="-120"/>
+              </a:rPr>
+              <a:t>A first look at government's toolkit</a:t>
+            </a:r>
+            <a:endParaRPr lang="en-US" sz="3200" dirty="0"/>
+          </a:p>
+        </p:txBody>
+      </p:sp>
+      <p:sp>
+        <p:nvSpPr>
+          <p:cNvPr id="3" name="Text 1"/>
+          <p:cNvSpPr/>
+          <p:nvPr/>
+        </p:nvSpPr>
+        <p:spPr>
+          <a:xfrm>
+            <a:off x="822960" y="1828800"/>
+            <a:ext cx="9875520" cy="4114800"/>
+          </a:xfrm>
+          <a:prstGeom prst="rect">
+            <a:avLst/>
+          </a:prstGeom>
+          <a:noFill/>
+          <a:ln/>
+        </p:spPr>
+        <p:txBody>
+          <a:bodyPr wrap="square" rtlCol="0" anchor="t"/>
+          <a:lstStyle/>
+          <a:p>
+            <a:pPr indent="0" marL="0">
+              <a:lnSpc>
+                <a:spcPct val="130000"/>
+              </a:lnSpc>
+              <a:spcAft>
+                <a:spcPts val="1400"/>
+              </a:spcAft>
+              <a:buNone/>
+            </a:pPr>
+            <a:r>
+              <a:rPr lang="en-US" sz="1800" dirty="0">
+                <a:solidFill>
+                  <a:srgbClr val="1A1A1A"/>
+                </a:solidFill>
+                <a:latin typeface="Calibri" pitchFamily="34" charset="0"/>
+                <a:ea typeface="Calibri" pitchFamily="34" charset="-122"/>
+                <a:cs typeface="Calibri" pitchFamily="34" charset="-120"/>
+              </a:rPr>
+              <a:t>Taxes — to discourage demerit goods and negative externalities.</a:t>
+            </a:r>
+            <a:endParaRPr lang="en-US" sz="1800" dirty="0"/>
+          </a:p>
+          <a:p>
+            <a:pPr indent="0" marL="0">
+              <a:lnSpc>
+                <a:spcPct val="130000"/>
+              </a:lnSpc>
+              <a:spcAft>
+                <a:spcPts val="1400"/>
+              </a:spcAft>
+              <a:buNone/>
+            </a:pPr>
+            <a:r>
+              <a:rPr lang="en-US" sz="1800" dirty="0">
+                <a:solidFill>
+                  <a:srgbClr val="1A1A1A"/>
+                </a:solidFill>
+                <a:latin typeface="Calibri" pitchFamily="34" charset="0"/>
+                <a:ea typeface="Calibri" pitchFamily="34" charset="-122"/>
+                <a:cs typeface="Calibri" pitchFamily="34" charset="-120"/>
+              </a:rPr>
+              <a:t>Subsidies — to encourage merit goods and positive externalities.</a:t>
+            </a:r>
+            <a:endParaRPr lang="en-US" sz="1800" dirty="0"/>
+          </a:p>
+          <a:p>
+            <a:pPr indent="0" marL="0">
+              <a:lnSpc>
+                <a:spcPct val="130000"/>
+              </a:lnSpc>
+              <a:spcAft>
+                <a:spcPts val="1400"/>
+              </a:spcAft>
+              <a:buNone/>
+            </a:pPr>
+            <a:r>
+              <a:rPr lang="en-US" sz="1800" dirty="0">
+                <a:solidFill>
+                  <a:srgbClr val="1A1A1A"/>
+                </a:solidFill>
+                <a:latin typeface="Calibri" pitchFamily="34" charset="0"/>
+                <a:ea typeface="Calibri" pitchFamily="34" charset="-122"/>
+                <a:cs typeface="Calibri" pitchFamily="34" charset="-120"/>
+              </a:rPr>
+              <a:t>Regulation — rules and limits on behaviour.</a:t>
+            </a:r>
+            <a:endParaRPr lang="en-US" sz="1800" dirty="0"/>
+          </a:p>
+          <a:p>
+            <a:pPr indent="0" marL="0">
+              <a:lnSpc>
+                <a:spcPct val="130000"/>
+              </a:lnSpc>
+              <a:spcAft>
+                <a:spcPts val="1400"/>
+              </a:spcAft>
+              <a:buNone/>
+            </a:pPr>
+            <a:r>
+              <a:rPr lang="en-US" sz="1800" dirty="0">
+                <a:solidFill>
+                  <a:srgbClr val="1A1A1A"/>
+                </a:solidFill>
+                <a:latin typeface="Calibri" pitchFamily="34" charset="0"/>
+                <a:ea typeface="Calibri" pitchFamily="34" charset="-122"/>
+                <a:cs typeface="Calibri" pitchFamily="34" charset="-120"/>
+              </a:rPr>
+              <a:t>Direct provision — government builds or provides public goods itself.</a:t>
+            </a:r>
+            <a:endParaRPr lang="en-US" sz="1800" dirty="0"/>
+          </a:p>
+        </p:txBody>
+      </p:sp>
+    </p:spTree>
+  </p:cSld>
+  <p:clrMapOvr>
+    <a:masterClrMapping/>
+  </p:clrMapOvr>
+</p:sld>
+</file>
+
+<file path=ppt/slides/slide28.xml><?xml version="1.0" encoding="utf-8"?>
+<p:sld xmlns:a="http://schemas.openxmlformats.org/drawingml/2006/main" xmlns:r="http://schemas.openxmlformats.org/officeDocument/2006/relationships" xmlns:p="http://schemas.openxmlformats.org/presentationml/2006/main">
+  <p:cSld name="Slide 28">
+    <p:bg>
+      <p:bgPr>
+        <a:solidFill>
+          <a:srgbClr val="FFFFFF"/>
+        </a:solidFill>
+      </p:bgPr>
+    </p:bg>
+    <p:spTree>
+      <p:nvGrpSpPr>
+        <p:cNvPr id="1" name=""/>
+        <p:cNvGrpSpPr/>
+        <p:nvPr/>
+      </p:nvGrpSpPr>
+      <p:grpSpPr>
+        <a:xfrm>
+          <a:off x="0" y="0"/>
+          <a:ext cx="0" cy="0"/>
+          <a:chOff x="0" y="0"/>
+          <a:chExt cx="0" cy="0"/>
+        </a:xfrm>
+      </p:grpSpPr>
+      <p:sp>
+        <p:nvSpPr>
+          <p:cNvPr id="2" name="Text 0"/>
+          <p:cNvSpPr/>
+          <p:nvPr/>
+        </p:nvSpPr>
+        <p:spPr>
+          <a:xfrm>
+            <a:off x="640080" y="548640"/>
+            <a:ext cx="10881360" cy="822960"/>
+          </a:xfrm>
+          <a:prstGeom prst="rect">
+            <a:avLst/>
+          </a:prstGeom>
+          <a:noFill/>
+          <a:ln/>
+        </p:spPr>
+        <p:txBody>
+          <a:bodyPr wrap="square" rtlCol="0" anchor="ctr"/>
+          <a:lstStyle/>
+          <a:p>
+            <a:pPr indent="0" marL="0">
+              <a:buNone/>
+            </a:pPr>
+            <a:r>
+              <a:rPr lang="en-US" sz="3200" b="1" dirty="0">
+                <a:solidFill>
+                  <a:srgbClr val="1E2761"/>
+                </a:solidFill>
+                <a:latin typeface="Cambria" pitchFamily="34" charset="0"/>
+                <a:ea typeface="Cambria" pitchFamily="34" charset="-122"/>
+                <a:cs typeface="Cambria" pitchFamily="34" charset="-120"/>
+              </a:rPr>
+              <a:t>Quick check: causes &amp; consequences</a:t>
+            </a:r>
+            <a:endParaRPr lang="en-US" sz="3200" dirty="0"/>
+          </a:p>
+        </p:txBody>
+      </p:sp>
+      <p:sp>
+        <p:nvSpPr>
+          <p:cNvPr id="3" name="Text 1"/>
+          <p:cNvSpPr/>
+          <p:nvPr/>
+        </p:nvSpPr>
+        <p:spPr>
+          <a:xfrm>
+            <a:off x="822960" y="1828800"/>
+            <a:ext cx="9875520" cy="4114800"/>
+          </a:xfrm>
+          <a:prstGeom prst="rect">
+            <a:avLst/>
+          </a:prstGeom>
+          <a:noFill/>
+          <a:ln/>
+        </p:spPr>
+        <p:txBody>
+          <a:bodyPr wrap="square" rtlCol="0" anchor="t"/>
+          <a:lstStyle/>
+          <a:p>
+            <a:pPr indent="0" marL="0">
+              <a:lnSpc>
+                <a:spcPct val="130000"/>
+              </a:lnSpc>
+              <a:spcAft>
+                <a:spcPts val="1400"/>
+              </a:spcAft>
+              <a:buNone/>
+            </a:pPr>
+            <a:r>
+              <a:rPr lang="en-US" sz="1800" dirty="0">
+                <a:solidFill>
+                  <a:srgbClr val="1A1A1A"/>
+                </a:solidFill>
+                <a:latin typeface="Calibri" pitchFamily="34" charset="0"/>
+                <a:ea typeface="Calibri" pitchFamily="34" charset="-122"/>
+                <a:cs typeface="Calibri" pitchFamily="34" charset="-120"/>
+              </a:rPr>
+              <a:t>A factory's negative externality — more or less than the socially efficient amount?</a:t>
+            </a:r>
+            <a:endParaRPr lang="en-US" sz="1800" dirty="0"/>
+          </a:p>
+          <a:p>
+            <a:pPr indent="0" marL="0">
+              <a:lnSpc>
+                <a:spcPct val="130000"/>
+              </a:lnSpc>
+              <a:spcAft>
+                <a:spcPts val="1400"/>
+              </a:spcAft>
+              <a:buNone/>
+            </a:pPr>
+            <a:r>
+              <a:rPr lang="en-US" sz="1800" dirty="0">
+                <a:solidFill>
+                  <a:srgbClr val="1A1A1A"/>
+                </a:solidFill>
+                <a:latin typeface="Calibri" pitchFamily="34" charset="0"/>
+                <a:ea typeface="Calibri" pitchFamily="34" charset="-122"/>
+                <a:cs typeface="Calibri" pitchFamily="34" charset="-120"/>
+              </a:rPr>
+              <a:t>Why does a merit good get under-provided by the market?</a:t>
+            </a:r>
+            <a:endParaRPr lang="en-US" sz="1800" dirty="0"/>
+          </a:p>
+          <a:p>
+            <a:pPr indent="0" marL="0">
+              <a:lnSpc>
+                <a:spcPct val="130000"/>
+              </a:lnSpc>
+              <a:spcAft>
+                <a:spcPts val="1400"/>
+              </a:spcAft>
+              <a:buNone/>
+            </a:pPr>
+            <a:r>
+              <a:rPr lang="en-US" sz="1800" dirty="0">
+                <a:solidFill>
+                  <a:srgbClr val="1A1A1A"/>
+                </a:solidFill>
+                <a:latin typeface="Calibri" pitchFamily="34" charset="0"/>
+                <a:ea typeface="Calibri" pitchFamily="34" charset="-122"/>
+                <a:cs typeface="Calibri" pitchFamily="34" charset="-120"/>
+              </a:rPr>
+              <a:t>What is the free-rider problem a direct cause of?</a:t>
+            </a:r>
+            <a:endParaRPr lang="en-US" sz="1800" dirty="0"/>
+          </a:p>
+        </p:txBody>
+      </p:sp>
+    </p:spTree>
+  </p:cSld>
+  <p:clrMapOvr>
+    <a:masterClrMapping/>
+  </p:clrMapOvr>
+</p:sld>
+</file>
+
+<file path=ppt/slides/slide29.xml><?xml version="1.0" encoding="utf-8"?>
+<p:sld xmlns:a="http://schemas.openxmlformats.org/drawingml/2006/main" xmlns:r="http://schemas.openxmlformats.org/officeDocument/2006/relationships" xmlns:p="http://schemas.openxmlformats.org/presentationml/2006/main">
+  <p:cSld name="Slide 29">
+    <p:bg>
+      <p:bgPr>
+        <a:solidFill>
+          <a:srgbClr val="FFFFFF"/>
+        </a:solidFill>
+      </p:bgPr>
+    </p:bg>
+    <p:spTree>
+      <p:nvGrpSpPr>
+        <p:cNvPr id="1" name=""/>
+        <p:cNvGrpSpPr/>
+        <p:nvPr/>
+      </p:nvGrpSpPr>
+      <p:grpSpPr>
+        <a:xfrm>
+          <a:off x="0" y="0"/>
+          <a:ext cx="0" cy="0"/>
+          <a:chOff x="0" y="0"/>
+          <a:chExt cx="0" cy="0"/>
+        </a:xfrm>
+      </p:grpSpPr>
+      <p:sp>
+        <p:nvSpPr>
+          <p:cNvPr id="2" name="Text 0"/>
+          <p:cNvSpPr/>
+          <p:nvPr/>
+        </p:nvSpPr>
+        <p:spPr>
+          <a:xfrm>
+            <a:off x="640080" y="548640"/>
+            <a:ext cx="10881360" cy="822960"/>
+          </a:xfrm>
+          <a:prstGeom prst="rect">
+            <a:avLst/>
+          </a:prstGeom>
+          <a:noFill/>
+          <a:ln/>
+        </p:spPr>
+        <p:txBody>
+          <a:bodyPr wrap="square" rtlCol="0" anchor="ctr"/>
+          <a:lstStyle/>
+          <a:p>
+            <a:pPr indent="0" marL="0">
+              <a:buNone/>
+            </a:pPr>
+            <a:r>
+              <a:rPr lang="en-US" sz="3200" b="1" dirty="0">
+                <a:solidFill>
+                  <a:srgbClr val="1E2761"/>
+                </a:solidFill>
+                <a:latin typeface="Cambria" pitchFamily="34" charset="0"/>
+                <a:ea typeface="Cambria" pitchFamily="34" charset="-122"/>
+                <a:cs typeface="Cambria" pitchFamily="34" charset="-120"/>
+              </a:rPr>
+              <a:t>Recap</a:t>
+            </a:r>
+            <a:endParaRPr lang="en-US" sz="3200" dirty="0"/>
+          </a:p>
+        </p:txBody>
+      </p:sp>
+      <p:sp>
+        <p:nvSpPr>
+          <p:cNvPr id="3" name="Text 1"/>
+          <p:cNvSpPr/>
+          <p:nvPr/>
+        </p:nvSpPr>
+        <p:spPr>
+          <a:xfrm>
+            <a:off x="822960" y="1828800"/>
+            <a:ext cx="9875520" cy="4114800"/>
+          </a:xfrm>
+          <a:prstGeom prst="rect">
+            <a:avLst/>
+          </a:prstGeom>
+          <a:noFill/>
+          <a:ln/>
+        </p:spPr>
+        <p:txBody>
+          <a:bodyPr wrap="square" rtlCol="0" anchor="t"/>
+          <a:lstStyle/>
+          <a:p>
+            <a:pPr indent="0" marL="0">
+              <a:lnSpc>
+                <a:spcPct val="130000"/>
+              </a:lnSpc>
+              <a:spcAft>
+                <a:spcPts val="1400"/>
+              </a:spcAft>
+              <a:buNone/>
+            </a:pPr>
+            <a:r>
+              <a:rPr lang="en-US" sz="1800" dirty="0">
+                <a:solidFill>
+                  <a:srgbClr val="1A1A1A"/>
+                </a:solidFill>
+                <a:latin typeface="Calibri" pitchFamily="34" charset="0"/>
+                <a:ea typeface="Calibri" pitchFamily="34" charset="-122"/>
+                <a:cs typeface="Calibri" pitchFamily="34" charset="-120"/>
+              </a:rPr>
+              <a:t>Market failure: the price mechanism misallocates resources.</a:t>
+            </a:r>
+            <a:endParaRPr lang="en-US" sz="1800" dirty="0"/>
+          </a:p>
+          <a:p>
+            <a:pPr indent="0" marL="0">
+              <a:lnSpc>
+                <a:spcPct val="130000"/>
+              </a:lnSpc>
+              <a:spcAft>
+                <a:spcPts val="1400"/>
+              </a:spcAft>
+              <a:buNone/>
+            </a:pPr>
+            <a:r>
+              <a:rPr lang="en-US" sz="1800" dirty="0">
+                <a:solidFill>
+                  <a:srgbClr val="1A1A1A"/>
+                </a:solidFill>
+                <a:latin typeface="Calibri" pitchFamily="34" charset="0"/>
+                <a:ea typeface="Calibri" pitchFamily="34" charset="-122"/>
+                <a:cs typeface="Calibri" pitchFamily="34" charset="-120"/>
+              </a:rPr>
+              <a:t>Externalities, public goods, and merit/demerit goods are the causes.</a:t>
+            </a:r>
+            <a:endParaRPr lang="en-US" sz="1800" dirty="0"/>
+          </a:p>
+          <a:p>
+            <a:pPr indent="0" marL="0">
+              <a:lnSpc>
+                <a:spcPct val="130000"/>
+              </a:lnSpc>
+              <a:spcAft>
+                <a:spcPts val="1400"/>
+              </a:spcAft>
+              <a:buNone/>
+            </a:pPr>
+            <a:r>
+              <a:rPr lang="en-US" sz="1800" dirty="0">
+                <a:solidFill>
+                  <a:srgbClr val="1A1A1A"/>
+                </a:solidFill>
+                <a:latin typeface="Calibri" pitchFamily="34" charset="0"/>
+                <a:ea typeface="Calibri" pitchFamily="34" charset="-122"/>
+                <a:cs typeface="Calibri" pitchFamily="34" charset="-120"/>
+              </a:rPr>
+              <a:t>Negative externalities cause overproduction. Positive externalities and merit goods cause underproduction. Public goods get zero private provision.</a:t>
+            </a:r>
+            <a:endParaRPr lang="en-US" sz="1800" dirty="0"/>
+          </a:p>
+          <a:p>
+            <a:pPr indent="0" marL="0">
+              <a:lnSpc>
+                <a:spcPct val="130000"/>
+              </a:lnSpc>
+              <a:spcAft>
+                <a:spcPts val="1400"/>
+              </a:spcAft>
+              <a:buNone/>
+            </a:pPr>
+            <a:r>
+              <a:rPr lang="en-US" sz="1800" dirty="0">
+                <a:solidFill>
+                  <a:srgbClr val="1A1A1A"/>
+                </a:solidFill>
+                <a:latin typeface="Calibri" pitchFamily="34" charset="0"/>
+                <a:ea typeface="Calibri" pitchFamily="34" charset="-122"/>
+                <a:cs typeface="Calibri" pitchFamily="34" charset="-120"/>
+              </a:rPr>
+              <a:t>Consumers, producers, and government are all affected differently.</a:t>
             </a:r>
             <a:endParaRPr lang="en-US" sz="1800" dirty="0"/>
           </a:p>
@@ -5848,6 +8326,155 @@
               <a:t>TR after = $____</a:t>
             </a:r>
             <a:endParaRPr lang="en-US" sz="1400" dirty="0"/>
+          </a:p>
+        </p:txBody>
+      </p:sp>
+    </p:spTree>
+  </p:cSld>
+  <p:clrMapOvr>
+    <a:masterClrMapping/>
+  </p:clrMapOvr>
+</p:sld>
+</file>
+
+<file path=ppt/slides/slide30.xml><?xml version="1.0" encoding="utf-8"?>
+<p:sld xmlns:a="http://schemas.openxmlformats.org/drawingml/2006/main" xmlns:r="http://schemas.openxmlformats.org/officeDocument/2006/relationships" xmlns:p="http://schemas.openxmlformats.org/presentationml/2006/main">
+  <p:cSld name="Slide 30">
+    <p:bg>
+      <p:bgPr>
+        <a:solidFill>
+          <a:srgbClr val="1E2761"/>
+        </a:solidFill>
+      </p:bgPr>
+    </p:bg>
+    <p:spTree>
+      <p:nvGrpSpPr>
+        <p:cNvPr id="1" name=""/>
+        <p:cNvGrpSpPr/>
+        <p:nvPr/>
+      </p:nvGrpSpPr>
+      <p:grpSpPr>
+        <a:xfrm>
+          <a:off x="0" y="0"/>
+          <a:ext cx="0" cy="0"/>
+          <a:chOff x="0" y="0"/>
+          <a:chExt cx="0" cy="0"/>
+        </a:xfrm>
+      </p:grpSpPr>
+      <p:sp>
+        <p:nvSpPr>
+          <p:cNvPr id="2" name="Text 0"/>
+          <p:cNvSpPr/>
+          <p:nvPr/>
+        </p:nvSpPr>
+        <p:spPr>
+          <a:xfrm>
+            <a:off x="640080" y="2103120"/>
+            <a:ext cx="10881360" cy="457200"/>
+          </a:xfrm>
+          <a:prstGeom prst="rect">
+            <a:avLst/>
+          </a:prstGeom>
+          <a:noFill/>
+          <a:ln/>
+        </p:spPr>
+        <p:txBody>
+          <a:bodyPr wrap="square" rtlCol="0" anchor="ctr"/>
+          <a:lstStyle/>
+          <a:p>
+            <a:pPr indent="0" marL="0">
+              <a:buNone/>
+            </a:pPr>
+            <a:r>
+              <a:rPr lang="en-US" sz="1400" b="1" spc="200" kern="0" dirty="0">
+                <a:solidFill>
+                  <a:srgbClr val="CADCFC"/>
+                </a:solidFill>
+                <a:latin typeface="Calibri" pitchFamily="34" charset="0"/>
+                <a:ea typeface="Calibri" pitchFamily="34" charset="-122"/>
+                <a:cs typeface="Calibri" pitchFamily="34" charset="-120"/>
+              </a:rPr>
+              <a:t>NEXT LESSON</a:t>
+            </a:r>
+            <a:endParaRPr lang="en-US" sz="1400" dirty="0"/>
+          </a:p>
+        </p:txBody>
+      </p:sp>
+      <p:sp>
+        <p:nvSpPr>
+          <p:cNvPr id="3" name="Text 1"/>
+          <p:cNvSpPr/>
+          <p:nvPr/>
+        </p:nvSpPr>
+        <p:spPr>
+          <a:xfrm>
+            <a:off x="640080" y="2560320"/>
+            <a:ext cx="10881360" cy="1463040"/>
+          </a:xfrm>
+          <a:prstGeom prst="rect">
+            <a:avLst/>
+          </a:prstGeom>
+          <a:noFill/>
+          <a:ln/>
+        </p:spPr>
+        <p:txBody>
+          <a:bodyPr wrap="square" rtlCol="0" anchor="ctr"/>
+          <a:lstStyle/>
+          <a:p>
+            <a:pPr indent="0" marL="0">
+              <a:buNone/>
+            </a:pPr>
+            <a:r>
+              <a:rPr lang="en-US" sz="4400" b="1" dirty="0">
+                <a:solidFill>
+                  <a:srgbClr val="FFFFFF"/>
+                </a:solidFill>
+                <a:latin typeface="Cambria" pitchFamily="34" charset="0"/>
+                <a:ea typeface="Cambria" pitchFamily="34" charset="-122"/>
+                <a:cs typeface="Cambria" pitchFamily="34" charset="-120"/>
+              </a:rPr>
+              <a:t>Mixed economy &amp; price controls</a:t>
+            </a:r>
+            <a:endParaRPr lang="en-US" sz="4400" dirty="0"/>
+          </a:p>
+        </p:txBody>
+      </p:sp>
+      <p:sp>
+        <p:nvSpPr>
+          <p:cNvPr id="4" name="Text 2"/>
+          <p:cNvSpPr/>
+          <p:nvPr/>
+        </p:nvSpPr>
+        <p:spPr>
+          <a:xfrm>
+            <a:off x="640080" y="3931920"/>
+            <a:ext cx="9601200" cy="731520"/>
+          </a:xfrm>
+          <a:prstGeom prst="rect">
+            <a:avLst/>
+          </a:prstGeom>
+          <a:noFill/>
+          <a:ln/>
+        </p:spPr>
+        <p:txBody>
+          <a:bodyPr wrap="square" rtlCol="0" anchor="ctr"/>
+          <a:lstStyle/>
+          <a:p>
+            <a:pPr indent="0" marL="0">
+              <a:buNone/>
+            </a:pPr>
+            <a:r>
+              <a:rPr lang="en-US" sz="1800" dirty="0">
+                <a:solidFill>
+                  <a:srgbClr val="CADCFC"/>
+                </a:solidFill>
+                <a:latin typeface="Calibri" pitchFamily="34" charset="0"/>
+                <a:ea typeface="Calibri" pitchFamily="34" charset="-122"/>
+                <a:cs typeface="Calibri" pitchFamily="34" charset="-120"/>
+              </a:rPr>
+              <a:t>The actual tools — taxes, subsidies, regulation — in depth.</a:t>
+            </a:r>
+            <a:endParaRPr lang="en-US" sz="1800" dirty="0"/>
           </a:p>
         </p:txBody>
       </p:sp>

</xml_diff>